<commit_message>
Update Agentic Search Talk presentation draft
</commit_message>
<xml_diff>
--- a/docs/presentation/Agentic_Search_Talk_Draft_v1.pptx
+++ b/docs/presentation/Agentic_Search_Talk_Draft_v1.pptx
@@ -1081,7 +1081,7 @@
       </p:grpSpPr>
       <p:sp>
         <p:nvSpPr>
-          <p:cNvPr id="290" name="Google Shape;290;p15:notes"/>
+          <p:cNvPr id="290" name="Google Shape;290;p16:notes"/>
           <p:cNvSpPr txBox="1"/>
           <p:nvPr>
             <p:ph idx="1" type="body"/>
@@ -1128,7 +1128,7 @@
       </p:sp>
       <p:sp>
         <p:nvSpPr>
-          <p:cNvPr id="291" name="Google Shape;291;p15:notes"/>
+          <p:cNvPr id="291" name="Google Shape;291;p16:notes"/>
           <p:cNvSpPr/>
           <p:nvPr>
             <p:ph idx="2" type="sldImg"/>
@@ -1184,7 +1184,7 @@
   <p:cSld>
     <p:spTree>
       <p:nvGrpSpPr>
-        <p:cNvPr id="316" name="Shape 316"/>
+        <p:cNvPr id="302" name="Shape 302"/>
         <p:cNvGrpSpPr/>
         <p:nvPr/>
       </p:nvGrpSpPr>
@@ -1198,7 +1198,7 @@
       </p:grpSpPr>
       <p:sp>
         <p:nvSpPr>
-          <p:cNvPr id="317" name="Google Shape;317;p16:notes"/>
+          <p:cNvPr id="303" name="Google Shape;303;p15:notes"/>
           <p:cNvSpPr txBox="1"/>
           <p:nvPr>
             <p:ph idx="1" type="body"/>
@@ -1245,7 +1245,7 @@
       </p:sp>
       <p:sp>
         <p:nvSpPr>
-          <p:cNvPr id="318" name="Google Shape;318;p16:notes"/>
+          <p:cNvPr id="304" name="Google Shape;304;p15:notes"/>
           <p:cNvSpPr/>
           <p:nvPr>
             <p:ph idx="2" type="sldImg"/>
@@ -17016,7 +17016,7 @@
     <p:bg>
       <p:bgPr>
         <a:solidFill>
-          <a:srgbClr val="FFFFFF"/>
+          <a:srgbClr val="0A2540"/>
         </a:solidFill>
       </p:bgPr>
     </p:bg>
@@ -17037,1542 +17037,6 @@
       <p:sp>
         <p:nvSpPr>
           <p:cNvPr id="293" name="Google Shape;293;p24"/>
-          <p:cNvSpPr txBox="1"/>
-          <p:nvPr/>
-        </p:nvSpPr>
-        <p:spPr>
-          <a:xfrm>
-            <a:off x="365760" y="228600"/>
-            <a:ext cx="1371600" cy="138600"/>
-          </a:xfrm>
-          <a:prstGeom prst="rect">
-            <a:avLst/>
-          </a:prstGeom>
-          <a:noFill/>
-          <a:ln>
-            <a:noFill/>
-          </a:ln>
-        </p:spPr>
-        <p:txBody>
-          <a:bodyPr anchorCtr="0" anchor="t" bIns="0" lIns="0" spcFirstLastPara="1" rIns="0" wrap="square" tIns="0">
-            <a:spAutoFit/>
-          </a:bodyPr>
-          <a:lstStyle/>
-          <a:p>
-            <a:pPr indent="0" lvl="0" marL="0" marR="0" rtl="0" algn="l">
-              <a:lnSpc>
-                <a:spcPct val="100000"/>
-              </a:lnSpc>
-              <a:spcBef>
-                <a:spcPts val="0"/>
-              </a:spcBef>
-              <a:spcAft>
-                <a:spcPts val="0"/>
-              </a:spcAft>
-              <a:buClr>
-                <a:srgbClr val="000000"/>
-              </a:buClr>
-              <a:buSzPts val="900"/>
-              <a:buFont typeface="Arial"/>
-              <a:buNone/>
-            </a:pPr>
-            <a:r>
-              <a:rPr lang="en-US" sz="900">
-                <a:solidFill>
-                  <a:srgbClr val="94A3B8"/>
-                </a:solidFill>
-                <a:latin typeface="Calibri"/>
-                <a:ea typeface="Calibri"/>
-                <a:cs typeface="Calibri"/>
-                <a:sym typeface="Calibri"/>
-              </a:rPr>
-              <a:t>10 </a:t>
-            </a:r>
-            <a:r>
-              <a:rPr b="0" i="0" lang="en-US" sz="900" u="none" cap="none" strike="noStrike">
-                <a:solidFill>
-                  <a:srgbClr val="94A3B8"/>
-                </a:solidFill>
-                <a:latin typeface="Calibri"/>
-                <a:ea typeface="Calibri"/>
-                <a:cs typeface="Calibri"/>
-                <a:sym typeface="Calibri"/>
-              </a:rPr>
-              <a:t>/ </a:t>
-            </a:r>
-            <a:r>
-              <a:rPr lang="en-US" sz="900">
-                <a:solidFill>
-                  <a:srgbClr val="94A3B8"/>
-                </a:solidFill>
-                <a:latin typeface="Calibri"/>
-                <a:ea typeface="Calibri"/>
-                <a:cs typeface="Calibri"/>
-                <a:sym typeface="Calibri"/>
-              </a:rPr>
-              <a:t>11</a:t>
-            </a:r>
-            <a:endParaRPr sz="900">
-              <a:solidFill>
-                <a:srgbClr val="94A3B8"/>
-              </a:solidFill>
-              <a:latin typeface="Calibri"/>
-              <a:ea typeface="Calibri"/>
-              <a:cs typeface="Calibri"/>
-              <a:sym typeface="Calibri"/>
-            </a:endParaRPr>
-          </a:p>
-        </p:txBody>
-      </p:sp>
-      <p:sp>
-        <p:nvSpPr>
-          <p:cNvPr id="294" name="Google Shape;294;p24"/>
-          <p:cNvSpPr txBox="1"/>
-          <p:nvPr/>
-        </p:nvSpPr>
-        <p:spPr>
-          <a:xfrm>
-            <a:off x="1921298" y="6513375"/>
-            <a:ext cx="10058400" cy="138600"/>
-          </a:xfrm>
-          <a:prstGeom prst="rect">
-            <a:avLst/>
-          </a:prstGeom>
-          <a:noFill/>
-          <a:ln>
-            <a:noFill/>
-          </a:ln>
-        </p:spPr>
-        <p:txBody>
-          <a:bodyPr anchorCtr="0" anchor="t" bIns="0" lIns="0" spcFirstLastPara="1" rIns="0" wrap="square" tIns="0">
-            <a:spAutoFit/>
-          </a:bodyPr>
-          <a:lstStyle/>
-          <a:p>
-            <a:pPr indent="0" lvl="0" marL="0" marR="0" rtl="0" algn="r">
-              <a:lnSpc>
-                <a:spcPct val="100000"/>
-              </a:lnSpc>
-              <a:spcBef>
-                <a:spcPts val="0"/>
-              </a:spcBef>
-              <a:spcAft>
-                <a:spcPts val="0"/>
-              </a:spcAft>
-              <a:buClr>
-                <a:srgbClr val="000000"/>
-              </a:buClr>
-              <a:buSzPts val="900"/>
-              <a:buFont typeface="Arial"/>
-              <a:buNone/>
-            </a:pPr>
-            <a:r>
-              <a:rPr b="0" i="0" lang="en-US" sz="900" u="none" cap="none" strike="noStrike">
-                <a:solidFill>
-                  <a:srgbClr val="94A3B8"/>
-                </a:solidFill>
-                <a:latin typeface="Calibri"/>
-                <a:ea typeface="Calibri"/>
-                <a:cs typeface="Calibri"/>
-                <a:sym typeface="Calibri"/>
-              </a:rPr>
-              <a:t>OpenSearchCon NA 2026  ·  Agentic Search: Reimagining Search from Ingestion to Relevancy</a:t>
-            </a:r>
-            <a:endParaRPr b="0" i="0" sz="1400" u="none" cap="none" strike="noStrike">
-              <a:solidFill>
-                <a:srgbClr val="000000"/>
-              </a:solidFill>
-              <a:latin typeface="Arial"/>
-              <a:ea typeface="Arial"/>
-              <a:cs typeface="Arial"/>
-              <a:sym typeface="Arial"/>
-            </a:endParaRPr>
-          </a:p>
-        </p:txBody>
-      </p:sp>
-      <p:sp>
-        <p:nvSpPr>
-          <p:cNvPr id="295" name="Google Shape;295;p24"/>
-          <p:cNvSpPr txBox="1"/>
-          <p:nvPr/>
-        </p:nvSpPr>
-        <p:spPr>
-          <a:xfrm>
-            <a:off x="457200" y="594360"/>
-            <a:ext cx="11247120" cy="292608"/>
-          </a:xfrm>
-          <a:prstGeom prst="rect">
-            <a:avLst/>
-          </a:prstGeom>
-          <a:noFill/>
-          <a:ln>
-            <a:noFill/>
-          </a:ln>
-        </p:spPr>
-        <p:txBody>
-          <a:bodyPr anchorCtr="0" anchor="t" bIns="0" lIns="0" spcFirstLastPara="1" rIns="0" wrap="square" tIns="0">
-            <a:spAutoFit/>
-          </a:bodyPr>
-          <a:lstStyle/>
-          <a:p>
-            <a:pPr indent="0" lvl="0" marL="0" marR="0" rtl="0" algn="l">
-              <a:lnSpc>
-                <a:spcPct val="100000"/>
-              </a:lnSpc>
-              <a:spcBef>
-                <a:spcPts val="0"/>
-              </a:spcBef>
-              <a:spcAft>
-                <a:spcPts val="0"/>
-              </a:spcAft>
-              <a:buClr>
-                <a:srgbClr val="000000"/>
-              </a:buClr>
-              <a:buSzPts val="1200"/>
-              <a:buFont typeface="Arial"/>
-              <a:buNone/>
-            </a:pPr>
-            <a:r>
-              <a:rPr b="1" i="0" lang="en-US" sz="1200" u="none" cap="none" strike="noStrike">
-                <a:solidFill>
-                  <a:srgbClr val="0369A1"/>
-                </a:solidFill>
-                <a:latin typeface="Calibri"/>
-                <a:ea typeface="Calibri"/>
-                <a:cs typeface="Calibri"/>
-                <a:sym typeface="Calibri"/>
-              </a:rPr>
-              <a:t>SOURCES</a:t>
-            </a:r>
-            <a:endParaRPr b="0" i="0" sz="1400" u="none" cap="none" strike="noStrike">
-              <a:solidFill>
-                <a:srgbClr val="000000"/>
-              </a:solidFill>
-              <a:latin typeface="Arial"/>
-              <a:ea typeface="Arial"/>
-              <a:cs typeface="Arial"/>
-              <a:sym typeface="Arial"/>
-            </a:endParaRPr>
-          </a:p>
-        </p:txBody>
-      </p:sp>
-      <p:sp>
-        <p:nvSpPr>
-          <p:cNvPr id="296" name="Google Shape;296;p24"/>
-          <p:cNvSpPr txBox="1"/>
-          <p:nvPr/>
-        </p:nvSpPr>
-        <p:spPr>
-          <a:xfrm>
-            <a:off x="457200" y="960120"/>
-            <a:ext cx="11247120" cy="777240"/>
-          </a:xfrm>
-          <a:prstGeom prst="rect">
-            <a:avLst/>
-          </a:prstGeom>
-          <a:noFill/>
-          <a:ln>
-            <a:noFill/>
-          </a:ln>
-        </p:spPr>
-        <p:txBody>
-          <a:bodyPr anchorCtr="0" anchor="t" bIns="0" lIns="0" spcFirstLastPara="1" rIns="0" wrap="square" tIns="0">
-            <a:spAutoFit/>
-          </a:bodyPr>
-          <a:lstStyle/>
-          <a:p>
-            <a:pPr indent="0" lvl="0" marL="0" marR="0" rtl="0" algn="l">
-              <a:lnSpc>
-                <a:spcPct val="100000"/>
-              </a:lnSpc>
-              <a:spcBef>
-                <a:spcPts val="0"/>
-              </a:spcBef>
-              <a:spcAft>
-                <a:spcPts val="0"/>
-              </a:spcAft>
-              <a:buClr>
-                <a:srgbClr val="000000"/>
-              </a:buClr>
-              <a:buSzPts val="3200"/>
-              <a:buFont typeface="Arial"/>
-              <a:buNone/>
-            </a:pPr>
-            <a:r>
-              <a:rPr b="1" i="0" lang="en-US" sz="3200" u="none" cap="none" strike="noStrike">
-                <a:solidFill>
-                  <a:srgbClr val="0A2540"/>
-                </a:solidFill>
-                <a:latin typeface="Calibri"/>
-                <a:ea typeface="Calibri"/>
-                <a:cs typeface="Calibri"/>
-                <a:sym typeface="Calibri"/>
-              </a:rPr>
-              <a:t>References</a:t>
-            </a:r>
-            <a:endParaRPr b="0" i="0" sz="1400" u="none" cap="none" strike="noStrike">
-              <a:solidFill>
-                <a:srgbClr val="000000"/>
-              </a:solidFill>
-              <a:latin typeface="Arial"/>
-              <a:ea typeface="Arial"/>
-              <a:cs typeface="Arial"/>
-              <a:sym typeface="Arial"/>
-            </a:endParaRPr>
-          </a:p>
-        </p:txBody>
-      </p:sp>
-      <p:sp>
-        <p:nvSpPr>
-          <p:cNvPr id="297" name="Google Shape;297;p24"/>
-          <p:cNvSpPr txBox="1"/>
-          <p:nvPr/>
-        </p:nvSpPr>
-        <p:spPr>
-          <a:xfrm>
-            <a:off x="457200" y="1965960"/>
-            <a:ext cx="4023360" cy="274320"/>
-          </a:xfrm>
-          <a:prstGeom prst="rect">
-            <a:avLst/>
-          </a:prstGeom>
-          <a:noFill/>
-          <a:ln>
-            <a:noFill/>
-          </a:ln>
-        </p:spPr>
-        <p:txBody>
-          <a:bodyPr anchorCtr="0" anchor="t" bIns="0" lIns="0" spcFirstLastPara="1" rIns="0" wrap="square" tIns="0">
-            <a:spAutoFit/>
-          </a:bodyPr>
-          <a:lstStyle/>
-          <a:p>
-            <a:pPr indent="0" lvl="0" marL="0" marR="0" rtl="0" algn="l">
-              <a:lnSpc>
-                <a:spcPct val="100000"/>
-              </a:lnSpc>
-              <a:spcBef>
-                <a:spcPts val="0"/>
-              </a:spcBef>
-              <a:spcAft>
-                <a:spcPts val="0"/>
-              </a:spcAft>
-              <a:buClr>
-                <a:srgbClr val="000000"/>
-              </a:buClr>
-              <a:buSzPts val="1300"/>
-              <a:buFont typeface="Arial"/>
-              <a:buNone/>
-            </a:pPr>
-            <a:r>
-              <a:rPr b="1" i="0" lang="en-US" sz="1300" u="none" cap="none" strike="noStrike">
-                <a:solidFill>
-                  <a:srgbClr val="0A2540"/>
-                </a:solidFill>
-                <a:latin typeface="Calibri"/>
-                <a:ea typeface="Calibri"/>
-                <a:cs typeface="Calibri"/>
-                <a:sym typeface="Calibri"/>
-              </a:rPr>
-              <a:t>Search Relevance Workbench</a:t>
-            </a:r>
-            <a:endParaRPr b="0" i="0" sz="1400" u="none" cap="none" strike="noStrike">
-              <a:solidFill>
-                <a:srgbClr val="000000"/>
-              </a:solidFill>
-              <a:latin typeface="Arial"/>
-              <a:ea typeface="Arial"/>
-              <a:cs typeface="Arial"/>
-              <a:sym typeface="Arial"/>
-            </a:endParaRPr>
-          </a:p>
-        </p:txBody>
-      </p:sp>
-      <p:sp>
-        <p:nvSpPr>
-          <p:cNvPr id="298" name="Google Shape;298;p24"/>
-          <p:cNvSpPr txBox="1"/>
-          <p:nvPr/>
-        </p:nvSpPr>
-        <p:spPr>
-          <a:xfrm>
-            <a:off x="4572000" y="1965960"/>
-            <a:ext cx="7223760" cy="274320"/>
-          </a:xfrm>
-          <a:prstGeom prst="rect">
-            <a:avLst/>
-          </a:prstGeom>
-          <a:noFill/>
-          <a:ln>
-            <a:noFill/>
-          </a:ln>
-        </p:spPr>
-        <p:txBody>
-          <a:bodyPr anchorCtr="0" anchor="t" bIns="0" lIns="0" spcFirstLastPara="1" rIns="0" wrap="square" tIns="0">
-            <a:spAutoFit/>
-          </a:bodyPr>
-          <a:lstStyle/>
-          <a:p>
-            <a:pPr indent="0" lvl="0" marL="0" marR="0" rtl="0" algn="l">
-              <a:lnSpc>
-                <a:spcPct val="100000"/>
-              </a:lnSpc>
-              <a:spcBef>
-                <a:spcPts val="0"/>
-              </a:spcBef>
-              <a:spcAft>
-                <a:spcPts val="0"/>
-              </a:spcAft>
-              <a:buClr>
-                <a:srgbClr val="000000"/>
-              </a:buClr>
-              <a:buSzPts val="1200"/>
-              <a:buFont typeface="Arial"/>
-              <a:buNone/>
-            </a:pPr>
-            <a:r>
-              <a:rPr b="0" i="0" lang="en-US" sz="1200" u="none" cap="none" strike="noStrike">
-                <a:solidFill>
-                  <a:srgbClr val="0369A1"/>
-                </a:solidFill>
-                <a:latin typeface="Calibri"/>
-                <a:ea typeface="Calibri"/>
-                <a:cs typeface="Calibri"/>
-                <a:sym typeface="Calibri"/>
-              </a:rPr>
-              <a:t>docs.opensearch.org/latest/search-plugins/search-relevance/using-search-relevance-workbench/</a:t>
-            </a:r>
-            <a:endParaRPr b="0" i="0" sz="1400" u="none" cap="none" strike="noStrike">
-              <a:solidFill>
-                <a:srgbClr val="000000"/>
-              </a:solidFill>
-              <a:latin typeface="Arial"/>
-              <a:ea typeface="Arial"/>
-              <a:cs typeface="Arial"/>
-              <a:sym typeface="Arial"/>
-            </a:endParaRPr>
-          </a:p>
-        </p:txBody>
-      </p:sp>
-      <p:sp>
-        <p:nvSpPr>
-          <p:cNvPr id="299" name="Google Shape;299;p24"/>
-          <p:cNvSpPr txBox="1"/>
-          <p:nvPr/>
-        </p:nvSpPr>
-        <p:spPr>
-          <a:xfrm>
-            <a:off x="457200" y="2441448"/>
-            <a:ext cx="4023360" cy="274320"/>
-          </a:xfrm>
-          <a:prstGeom prst="rect">
-            <a:avLst/>
-          </a:prstGeom>
-          <a:noFill/>
-          <a:ln>
-            <a:noFill/>
-          </a:ln>
-        </p:spPr>
-        <p:txBody>
-          <a:bodyPr anchorCtr="0" anchor="t" bIns="0" lIns="0" spcFirstLastPara="1" rIns="0" wrap="square" tIns="0">
-            <a:spAutoFit/>
-          </a:bodyPr>
-          <a:lstStyle/>
-          <a:p>
-            <a:pPr indent="0" lvl="0" marL="0" marR="0" rtl="0" algn="l">
-              <a:lnSpc>
-                <a:spcPct val="100000"/>
-              </a:lnSpc>
-              <a:spcBef>
-                <a:spcPts val="0"/>
-              </a:spcBef>
-              <a:spcAft>
-                <a:spcPts val="0"/>
-              </a:spcAft>
-              <a:buClr>
-                <a:srgbClr val="000000"/>
-              </a:buClr>
-              <a:buSzPts val="1300"/>
-              <a:buFont typeface="Arial"/>
-              <a:buNone/>
-            </a:pPr>
-            <a:r>
-              <a:rPr b="1" i="0" lang="en-US" sz="1300" u="none" cap="none" strike="noStrike">
-                <a:solidFill>
-                  <a:srgbClr val="0A2540"/>
-                </a:solidFill>
-                <a:latin typeface="Calibri"/>
-                <a:ea typeface="Calibri"/>
-                <a:cs typeface="Calibri"/>
-                <a:sym typeface="Calibri"/>
-              </a:rPr>
-              <a:t>Judgments</a:t>
-            </a:r>
-            <a:endParaRPr b="0" i="0" sz="1400" u="none" cap="none" strike="noStrike">
-              <a:solidFill>
-                <a:srgbClr val="000000"/>
-              </a:solidFill>
-              <a:latin typeface="Arial"/>
-              <a:ea typeface="Arial"/>
-              <a:cs typeface="Arial"/>
-              <a:sym typeface="Arial"/>
-            </a:endParaRPr>
-          </a:p>
-        </p:txBody>
-      </p:sp>
-      <p:sp>
-        <p:nvSpPr>
-          <p:cNvPr id="300" name="Google Shape;300;p24"/>
-          <p:cNvSpPr txBox="1"/>
-          <p:nvPr/>
-        </p:nvSpPr>
-        <p:spPr>
-          <a:xfrm>
-            <a:off x="4572000" y="2441448"/>
-            <a:ext cx="7223760" cy="274320"/>
-          </a:xfrm>
-          <a:prstGeom prst="rect">
-            <a:avLst/>
-          </a:prstGeom>
-          <a:noFill/>
-          <a:ln>
-            <a:noFill/>
-          </a:ln>
-        </p:spPr>
-        <p:txBody>
-          <a:bodyPr anchorCtr="0" anchor="t" bIns="0" lIns="0" spcFirstLastPara="1" rIns="0" wrap="square" tIns="0">
-            <a:spAutoFit/>
-          </a:bodyPr>
-          <a:lstStyle/>
-          <a:p>
-            <a:pPr indent="0" lvl="0" marL="0" marR="0" rtl="0" algn="l">
-              <a:lnSpc>
-                <a:spcPct val="100000"/>
-              </a:lnSpc>
-              <a:spcBef>
-                <a:spcPts val="0"/>
-              </a:spcBef>
-              <a:spcAft>
-                <a:spcPts val="0"/>
-              </a:spcAft>
-              <a:buClr>
-                <a:srgbClr val="000000"/>
-              </a:buClr>
-              <a:buSzPts val="1200"/>
-              <a:buFont typeface="Arial"/>
-              <a:buNone/>
-            </a:pPr>
-            <a:r>
-              <a:rPr b="0" i="0" lang="en-US" sz="1200" u="none" cap="none" strike="noStrike">
-                <a:solidFill>
-                  <a:srgbClr val="0369A1"/>
-                </a:solidFill>
-                <a:latin typeface="Calibri"/>
-                <a:ea typeface="Calibri"/>
-                <a:cs typeface="Calibri"/>
-                <a:sym typeface="Calibri"/>
-              </a:rPr>
-              <a:t>docs.opensearch.org/latest/search-plugins/search-relevance/judgments/</a:t>
-            </a:r>
-            <a:endParaRPr b="0" i="0" sz="1400" u="none" cap="none" strike="noStrike">
-              <a:solidFill>
-                <a:srgbClr val="000000"/>
-              </a:solidFill>
-              <a:latin typeface="Arial"/>
-              <a:ea typeface="Arial"/>
-              <a:cs typeface="Arial"/>
-              <a:sym typeface="Arial"/>
-            </a:endParaRPr>
-          </a:p>
-        </p:txBody>
-      </p:sp>
-      <p:sp>
-        <p:nvSpPr>
-          <p:cNvPr id="301" name="Google Shape;301;p24"/>
-          <p:cNvSpPr txBox="1"/>
-          <p:nvPr/>
-        </p:nvSpPr>
-        <p:spPr>
-          <a:xfrm>
-            <a:off x="457200" y="2916936"/>
-            <a:ext cx="4023360" cy="274320"/>
-          </a:xfrm>
-          <a:prstGeom prst="rect">
-            <a:avLst/>
-          </a:prstGeom>
-          <a:noFill/>
-          <a:ln>
-            <a:noFill/>
-          </a:ln>
-        </p:spPr>
-        <p:txBody>
-          <a:bodyPr anchorCtr="0" anchor="t" bIns="0" lIns="0" spcFirstLastPara="1" rIns="0" wrap="square" tIns="0">
-            <a:spAutoFit/>
-          </a:bodyPr>
-          <a:lstStyle/>
-          <a:p>
-            <a:pPr indent="0" lvl="0" marL="0" marR="0" rtl="0" algn="l">
-              <a:lnSpc>
-                <a:spcPct val="100000"/>
-              </a:lnSpc>
-              <a:spcBef>
-                <a:spcPts val="0"/>
-              </a:spcBef>
-              <a:spcAft>
-                <a:spcPts val="0"/>
-              </a:spcAft>
-              <a:buClr>
-                <a:srgbClr val="000000"/>
-              </a:buClr>
-              <a:buSzPts val="1300"/>
-              <a:buFont typeface="Arial"/>
-              <a:buNone/>
-            </a:pPr>
-            <a:r>
-              <a:rPr b="1" i="0" lang="en-US" sz="1300" u="none" cap="none" strike="noStrike">
-                <a:solidFill>
-                  <a:srgbClr val="0A2540"/>
-                </a:solidFill>
-                <a:latin typeface="Calibri"/>
-                <a:ea typeface="Calibri"/>
-                <a:cs typeface="Calibri"/>
-                <a:sym typeface="Calibri"/>
-              </a:rPr>
-              <a:t>Evaluating search quality</a:t>
-            </a:r>
-            <a:endParaRPr b="0" i="0" sz="1400" u="none" cap="none" strike="noStrike">
-              <a:solidFill>
-                <a:srgbClr val="000000"/>
-              </a:solidFill>
-              <a:latin typeface="Arial"/>
-              <a:ea typeface="Arial"/>
-              <a:cs typeface="Arial"/>
-              <a:sym typeface="Arial"/>
-            </a:endParaRPr>
-          </a:p>
-        </p:txBody>
-      </p:sp>
-      <p:sp>
-        <p:nvSpPr>
-          <p:cNvPr id="302" name="Google Shape;302;p24"/>
-          <p:cNvSpPr txBox="1"/>
-          <p:nvPr/>
-        </p:nvSpPr>
-        <p:spPr>
-          <a:xfrm>
-            <a:off x="4572000" y="2916936"/>
-            <a:ext cx="7223760" cy="274320"/>
-          </a:xfrm>
-          <a:prstGeom prst="rect">
-            <a:avLst/>
-          </a:prstGeom>
-          <a:noFill/>
-          <a:ln>
-            <a:noFill/>
-          </a:ln>
-        </p:spPr>
-        <p:txBody>
-          <a:bodyPr anchorCtr="0" anchor="t" bIns="0" lIns="0" spcFirstLastPara="1" rIns="0" wrap="square" tIns="0">
-            <a:spAutoFit/>
-          </a:bodyPr>
-          <a:lstStyle/>
-          <a:p>
-            <a:pPr indent="0" lvl="0" marL="0" marR="0" rtl="0" algn="l">
-              <a:lnSpc>
-                <a:spcPct val="100000"/>
-              </a:lnSpc>
-              <a:spcBef>
-                <a:spcPts val="0"/>
-              </a:spcBef>
-              <a:spcAft>
-                <a:spcPts val="0"/>
-              </a:spcAft>
-              <a:buClr>
-                <a:srgbClr val="000000"/>
-              </a:buClr>
-              <a:buSzPts val="1200"/>
-              <a:buFont typeface="Arial"/>
-              <a:buNone/>
-            </a:pPr>
-            <a:r>
-              <a:rPr b="0" i="0" lang="en-US" sz="1200" u="none" cap="none" strike="noStrike">
-                <a:solidFill>
-                  <a:srgbClr val="0369A1"/>
-                </a:solidFill>
-                <a:latin typeface="Calibri"/>
-                <a:ea typeface="Calibri"/>
-                <a:cs typeface="Calibri"/>
-                <a:sym typeface="Calibri"/>
-              </a:rPr>
-              <a:t>docs.opensearch.org/latest/search-plugins/search-relevance/evaluate-search-quality/</a:t>
-            </a:r>
-            <a:endParaRPr b="0" i="0" sz="1400" u="none" cap="none" strike="noStrike">
-              <a:solidFill>
-                <a:srgbClr val="000000"/>
-              </a:solidFill>
-              <a:latin typeface="Arial"/>
-              <a:ea typeface="Arial"/>
-              <a:cs typeface="Arial"/>
-              <a:sym typeface="Arial"/>
-            </a:endParaRPr>
-          </a:p>
-        </p:txBody>
-      </p:sp>
-      <p:sp>
-        <p:nvSpPr>
-          <p:cNvPr id="303" name="Google Shape;303;p24"/>
-          <p:cNvSpPr txBox="1"/>
-          <p:nvPr/>
-        </p:nvSpPr>
-        <p:spPr>
-          <a:xfrm>
-            <a:off x="457200" y="3392424"/>
-            <a:ext cx="4023360" cy="274320"/>
-          </a:xfrm>
-          <a:prstGeom prst="rect">
-            <a:avLst/>
-          </a:prstGeom>
-          <a:noFill/>
-          <a:ln>
-            <a:noFill/>
-          </a:ln>
-        </p:spPr>
-        <p:txBody>
-          <a:bodyPr anchorCtr="0" anchor="t" bIns="0" lIns="0" spcFirstLastPara="1" rIns="0" wrap="square" tIns="0">
-            <a:spAutoFit/>
-          </a:bodyPr>
-          <a:lstStyle/>
-          <a:p>
-            <a:pPr indent="0" lvl="0" marL="0" marR="0" rtl="0" algn="l">
-              <a:lnSpc>
-                <a:spcPct val="100000"/>
-              </a:lnSpc>
-              <a:spcBef>
-                <a:spcPts val="0"/>
-              </a:spcBef>
-              <a:spcAft>
-                <a:spcPts val="0"/>
-              </a:spcAft>
-              <a:buClr>
-                <a:srgbClr val="000000"/>
-              </a:buClr>
-              <a:buSzPts val="1300"/>
-              <a:buFont typeface="Arial"/>
-              <a:buNone/>
-            </a:pPr>
-            <a:r>
-              <a:rPr b="1" i="0" lang="en-US" sz="1300" u="none" cap="none" strike="noStrike">
-                <a:solidFill>
-                  <a:srgbClr val="0A2540"/>
-                </a:solidFill>
-                <a:latin typeface="Calibri"/>
-                <a:ea typeface="Calibri"/>
-                <a:cs typeface="Calibri"/>
-                <a:sym typeface="Calibri"/>
-              </a:rPr>
-              <a:t>Optimizing hybrid search</a:t>
-            </a:r>
-            <a:endParaRPr b="0" i="0" sz="1400" u="none" cap="none" strike="noStrike">
-              <a:solidFill>
-                <a:srgbClr val="000000"/>
-              </a:solidFill>
-              <a:latin typeface="Arial"/>
-              <a:ea typeface="Arial"/>
-              <a:cs typeface="Arial"/>
-              <a:sym typeface="Arial"/>
-            </a:endParaRPr>
-          </a:p>
-        </p:txBody>
-      </p:sp>
-      <p:sp>
-        <p:nvSpPr>
-          <p:cNvPr id="304" name="Google Shape;304;p24"/>
-          <p:cNvSpPr txBox="1"/>
-          <p:nvPr/>
-        </p:nvSpPr>
-        <p:spPr>
-          <a:xfrm>
-            <a:off x="4572000" y="3392424"/>
-            <a:ext cx="7223760" cy="274320"/>
-          </a:xfrm>
-          <a:prstGeom prst="rect">
-            <a:avLst/>
-          </a:prstGeom>
-          <a:noFill/>
-          <a:ln>
-            <a:noFill/>
-          </a:ln>
-        </p:spPr>
-        <p:txBody>
-          <a:bodyPr anchorCtr="0" anchor="t" bIns="0" lIns="0" spcFirstLastPara="1" rIns="0" wrap="square" tIns="0">
-            <a:spAutoFit/>
-          </a:bodyPr>
-          <a:lstStyle/>
-          <a:p>
-            <a:pPr indent="0" lvl="0" marL="0" marR="0" rtl="0" algn="l">
-              <a:lnSpc>
-                <a:spcPct val="100000"/>
-              </a:lnSpc>
-              <a:spcBef>
-                <a:spcPts val="0"/>
-              </a:spcBef>
-              <a:spcAft>
-                <a:spcPts val="0"/>
-              </a:spcAft>
-              <a:buClr>
-                <a:srgbClr val="000000"/>
-              </a:buClr>
-              <a:buSzPts val="1200"/>
-              <a:buFont typeface="Arial"/>
-              <a:buNone/>
-            </a:pPr>
-            <a:r>
-              <a:rPr b="0" i="0" lang="en-US" sz="1200" u="none" cap="none" strike="noStrike">
-                <a:solidFill>
-                  <a:srgbClr val="0369A1"/>
-                </a:solidFill>
-                <a:latin typeface="Calibri"/>
-                <a:ea typeface="Calibri"/>
-                <a:cs typeface="Calibri"/>
-                <a:sym typeface="Calibri"/>
-              </a:rPr>
-              <a:t>docs.opensearch.org/latest/search-plugins/search-relevance/optimize-hybrid-search/</a:t>
-            </a:r>
-            <a:endParaRPr b="0" i="0" sz="1400" u="none" cap="none" strike="noStrike">
-              <a:solidFill>
-                <a:srgbClr val="000000"/>
-              </a:solidFill>
-              <a:latin typeface="Arial"/>
-              <a:ea typeface="Arial"/>
-              <a:cs typeface="Arial"/>
-              <a:sym typeface="Arial"/>
-            </a:endParaRPr>
-          </a:p>
-        </p:txBody>
-      </p:sp>
-      <p:sp>
-        <p:nvSpPr>
-          <p:cNvPr id="305" name="Google Shape;305;p24"/>
-          <p:cNvSpPr txBox="1"/>
-          <p:nvPr/>
-        </p:nvSpPr>
-        <p:spPr>
-          <a:xfrm>
-            <a:off x="457200" y="3867912"/>
-            <a:ext cx="4023360" cy="274320"/>
-          </a:xfrm>
-          <a:prstGeom prst="rect">
-            <a:avLst/>
-          </a:prstGeom>
-          <a:noFill/>
-          <a:ln>
-            <a:noFill/>
-          </a:ln>
-        </p:spPr>
-        <p:txBody>
-          <a:bodyPr anchorCtr="0" anchor="t" bIns="0" lIns="0" spcFirstLastPara="1" rIns="0" wrap="square" tIns="0">
-            <a:spAutoFit/>
-          </a:bodyPr>
-          <a:lstStyle/>
-          <a:p>
-            <a:pPr indent="0" lvl="0" marL="0" marR="0" rtl="0" algn="l">
-              <a:lnSpc>
-                <a:spcPct val="100000"/>
-              </a:lnSpc>
-              <a:spcBef>
-                <a:spcPts val="0"/>
-              </a:spcBef>
-              <a:spcAft>
-                <a:spcPts val="0"/>
-              </a:spcAft>
-              <a:buClr>
-                <a:srgbClr val="000000"/>
-              </a:buClr>
-              <a:buSzPts val="1300"/>
-              <a:buFont typeface="Arial"/>
-              <a:buNone/>
-            </a:pPr>
-            <a:r>
-              <a:rPr b="1" i="0" lang="en-US" sz="1300" u="none" cap="none" strike="noStrike">
-                <a:solidFill>
-                  <a:srgbClr val="0A2540"/>
-                </a:solidFill>
-                <a:latin typeface="Calibri"/>
-                <a:ea typeface="Calibri"/>
-                <a:cs typeface="Calibri"/>
-                <a:sym typeface="Calibri"/>
-              </a:rPr>
-              <a:t>Exploring experiment results</a:t>
-            </a:r>
-            <a:endParaRPr b="0" i="0" sz="1400" u="none" cap="none" strike="noStrike">
-              <a:solidFill>
-                <a:srgbClr val="000000"/>
-              </a:solidFill>
-              <a:latin typeface="Arial"/>
-              <a:ea typeface="Arial"/>
-              <a:cs typeface="Arial"/>
-              <a:sym typeface="Arial"/>
-            </a:endParaRPr>
-          </a:p>
-        </p:txBody>
-      </p:sp>
-      <p:sp>
-        <p:nvSpPr>
-          <p:cNvPr id="306" name="Google Shape;306;p24"/>
-          <p:cNvSpPr txBox="1"/>
-          <p:nvPr/>
-        </p:nvSpPr>
-        <p:spPr>
-          <a:xfrm>
-            <a:off x="4572000" y="3867912"/>
-            <a:ext cx="7223760" cy="274320"/>
-          </a:xfrm>
-          <a:prstGeom prst="rect">
-            <a:avLst/>
-          </a:prstGeom>
-          <a:noFill/>
-          <a:ln>
-            <a:noFill/>
-          </a:ln>
-        </p:spPr>
-        <p:txBody>
-          <a:bodyPr anchorCtr="0" anchor="t" bIns="0" lIns="0" spcFirstLastPara="1" rIns="0" wrap="square" tIns="0">
-            <a:spAutoFit/>
-          </a:bodyPr>
-          <a:lstStyle/>
-          <a:p>
-            <a:pPr indent="0" lvl="0" marL="0" marR="0" rtl="0" algn="l">
-              <a:lnSpc>
-                <a:spcPct val="100000"/>
-              </a:lnSpc>
-              <a:spcBef>
-                <a:spcPts val="0"/>
-              </a:spcBef>
-              <a:spcAft>
-                <a:spcPts val="0"/>
-              </a:spcAft>
-              <a:buClr>
-                <a:srgbClr val="000000"/>
-              </a:buClr>
-              <a:buSzPts val="1200"/>
-              <a:buFont typeface="Arial"/>
-              <a:buNone/>
-            </a:pPr>
-            <a:r>
-              <a:rPr b="0" i="0" lang="en-US" sz="1200" u="none" cap="none" strike="noStrike">
-                <a:solidFill>
-                  <a:srgbClr val="0369A1"/>
-                </a:solidFill>
-                <a:latin typeface="Calibri"/>
-                <a:ea typeface="Calibri"/>
-                <a:cs typeface="Calibri"/>
-                <a:sym typeface="Calibri"/>
-              </a:rPr>
-              <a:t>docs.opensearch.org/latest/search-plugins/search-relevance/explore-experiment-results/</a:t>
-            </a:r>
-            <a:endParaRPr b="0" i="0" sz="1400" u="none" cap="none" strike="noStrike">
-              <a:solidFill>
-                <a:srgbClr val="000000"/>
-              </a:solidFill>
-              <a:latin typeface="Arial"/>
-              <a:ea typeface="Arial"/>
-              <a:cs typeface="Arial"/>
-              <a:sym typeface="Arial"/>
-            </a:endParaRPr>
-          </a:p>
-        </p:txBody>
-      </p:sp>
-      <p:sp>
-        <p:nvSpPr>
-          <p:cNvPr id="307" name="Google Shape;307;p24"/>
-          <p:cNvSpPr txBox="1"/>
-          <p:nvPr/>
-        </p:nvSpPr>
-        <p:spPr>
-          <a:xfrm>
-            <a:off x="457200" y="4343400"/>
-            <a:ext cx="4023360" cy="274320"/>
-          </a:xfrm>
-          <a:prstGeom prst="rect">
-            <a:avLst/>
-          </a:prstGeom>
-          <a:noFill/>
-          <a:ln>
-            <a:noFill/>
-          </a:ln>
-        </p:spPr>
-        <p:txBody>
-          <a:bodyPr anchorCtr="0" anchor="t" bIns="0" lIns="0" spcFirstLastPara="1" rIns="0" wrap="square" tIns="0">
-            <a:spAutoFit/>
-          </a:bodyPr>
-          <a:lstStyle/>
-          <a:p>
-            <a:pPr indent="0" lvl="0" marL="0" marR="0" rtl="0" algn="l">
-              <a:lnSpc>
-                <a:spcPct val="100000"/>
-              </a:lnSpc>
-              <a:spcBef>
-                <a:spcPts val="0"/>
-              </a:spcBef>
-              <a:spcAft>
-                <a:spcPts val="0"/>
-              </a:spcAft>
-              <a:buClr>
-                <a:srgbClr val="000000"/>
-              </a:buClr>
-              <a:buSzPts val="1300"/>
-              <a:buFont typeface="Arial"/>
-              <a:buNone/>
-            </a:pPr>
-            <a:r>
-              <a:rPr b="1" i="0" lang="en-US" sz="1300" u="none" cap="none" strike="noStrike">
-                <a:solidFill>
-                  <a:srgbClr val="0A2540"/>
-                </a:solidFill>
-                <a:latin typeface="Calibri"/>
-                <a:ea typeface="Calibri"/>
-                <a:cs typeface="Calibri"/>
-                <a:sym typeface="Calibri"/>
-              </a:rPr>
-              <a:t>Monitoring search quality</a:t>
-            </a:r>
-            <a:endParaRPr b="0" i="0" sz="1400" u="none" cap="none" strike="noStrike">
-              <a:solidFill>
-                <a:srgbClr val="000000"/>
-              </a:solidFill>
-              <a:latin typeface="Arial"/>
-              <a:ea typeface="Arial"/>
-              <a:cs typeface="Arial"/>
-              <a:sym typeface="Arial"/>
-            </a:endParaRPr>
-          </a:p>
-        </p:txBody>
-      </p:sp>
-      <p:sp>
-        <p:nvSpPr>
-          <p:cNvPr id="308" name="Google Shape;308;p24"/>
-          <p:cNvSpPr txBox="1"/>
-          <p:nvPr/>
-        </p:nvSpPr>
-        <p:spPr>
-          <a:xfrm>
-            <a:off x="4572000" y="4343400"/>
-            <a:ext cx="7223760" cy="274320"/>
-          </a:xfrm>
-          <a:prstGeom prst="rect">
-            <a:avLst/>
-          </a:prstGeom>
-          <a:noFill/>
-          <a:ln>
-            <a:noFill/>
-          </a:ln>
-        </p:spPr>
-        <p:txBody>
-          <a:bodyPr anchorCtr="0" anchor="t" bIns="0" lIns="0" spcFirstLastPara="1" rIns="0" wrap="square" tIns="0">
-            <a:spAutoFit/>
-          </a:bodyPr>
-          <a:lstStyle/>
-          <a:p>
-            <a:pPr indent="0" lvl="0" marL="0" marR="0" rtl="0" algn="l">
-              <a:lnSpc>
-                <a:spcPct val="100000"/>
-              </a:lnSpc>
-              <a:spcBef>
-                <a:spcPts val="0"/>
-              </a:spcBef>
-              <a:spcAft>
-                <a:spcPts val="0"/>
-              </a:spcAft>
-              <a:buClr>
-                <a:srgbClr val="000000"/>
-              </a:buClr>
-              <a:buSzPts val="1200"/>
-              <a:buFont typeface="Arial"/>
-              <a:buNone/>
-            </a:pPr>
-            <a:r>
-              <a:rPr b="0" i="0" lang="en-US" sz="1200" u="none" cap="none" strike="noStrike">
-                <a:solidFill>
-                  <a:srgbClr val="0369A1"/>
-                </a:solidFill>
-                <a:latin typeface="Calibri"/>
-                <a:ea typeface="Calibri"/>
-                <a:cs typeface="Calibri"/>
-                <a:sym typeface="Calibri"/>
-              </a:rPr>
-              <a:t>docs.opensearch.org/latest/search-plugins/search-relevance/regularly-scheduled-experiments/</a:t>
-            </a:r>
-            <a:endParaRPr b="0" i="0" sz="1400" u="none" cap="none" strike="noStrike">
-              <a:solidFill>
-                <a:srgbClr val="000000"/>
-              </a:solidFill>
-              <a:latin typeface="Arial"/>
-              <a:ea typeface="Arial"/>
-              <a:cs typeface="Arial"/>
-              <a:sym typeface="Arial"/>
-            </a:endParaRPr>
-          </a:p>
-        </p:txBody>
-      </p:sp>
-      <p:sp>
-        <p:nvSpPr>
-          <p:cNvPr id="309" name="Google Shape;309;p24"/>
-          <p:cNvSpPr txBox="1"/>
-          <p:nvPr/>
-        </p:nvSpPr>
-        <p:spPr>
-          <a:xfrm>
-            <a:off x="457200" y="4818888"/>
-            <a:ext cx="4023360" cy="274320"/>
-          </a:xfrm>
-          <a:prstGeom prst="rect">
-            <a:avLst/>
-          </a:prstGeom>
-          <a:noFill/>
-          <a:ln>
-            <a:noFill/>
-          </a:ln>
-        </p:spPr>
-        <p:txBody>
-          <a:bodyPr anchorCtr="0" anchor="t" bIns="0" lIns="0" spcFirstLastPara="1" rIns="0" wrap="square" tIns="0">
-            <a:spAutoFit/>
-          </a:bodyPr>
-          <a:lstStyle/>
-          <a:p>
-            <a:pPr indent="0" lvl="0" marL="0" marR="0" rtl="0" algn="l">
-              <a:lnSpc>
-                <a:spcPct val="100000"/>
-              </a:lnSpc>
-              <a:spcBef>
-                <a:spcPts val="0"/>
-              </a:spcBef>
-              <a:spcAft>
-                <a:spcPts val="0"/>
-              </a:spcAft>
-              <a:buClr>
-                <a:srgbClr val="000000"/>
-              </a:buClr>
-              <a:buSzPts val="1300"/>
-              <a:buFont typeface="Arial"/>
-              <a:buNone/>
-            </a:pPr>
-            <a:r>
-              <a:rPr b="1" i="0" lang="en-US" sz="1300" u="none" cap="none" strike="noStrike">
-                <a:solidFill>
-                  <a:srgbClr val="0A2540"/>
-                </a:solidFill>
-                <a:latin typeface="Calibri"/>
-                <a:ea typeface="Calibri"/>
-                <a:cs typeface="Calibri"/>
-                <a:sym typeface="Calibri"/>
-              </a:rPr>
-              <a:t>Relevance agent</a:t>
-            </a:r>
-            <a:endParaRPr b="0" i="0" sz="1400" u="none" cap="none" strike="noStrike">
-              <a:solidFill>
-                <a:srgbClr val="000000"/>
-              </a:solidFill>
-              <a:latin typeface="Arial"/>
-              <a:ea typeface="Arial"/>
-              <a:cs typeface="Arial"/>
-              <a:sym typeface="Arial"/>
-            </a:endParaRPr>
-          </a:p>
-        </p:txBody>
-      </p:sp>
-      <p:sp>
-        <p:nvSpPr>
-          <p:cNvPr id="310" name="Google Shape;310;p24"/>
-          <p:cNvSpPr txBox="1"/>
-          <p:nvPr/>
-        </p:nvSpPr>
-        <p:spPr>
-          <a:xfrm>
-            <a:off x="4572000" y="4818888"/>
-            <a:ext cx="7223760" cy="274320"/>
-          </a:xfrm>
-          <a:prstGeom prst="rect">
-            <a:avLst/>
-          </a:prstGeom>
-          <a:noFill/>
-          <a:ln>
-            <a:noFill/>
-          </a:ln>
-        </p:spPr>
-        <p:txBody>
-          <a:bodyPr anchorCtr="0" anchor="t" bIns="0" lIns="0" spcFirstLastPara="1" rIns="0" wrap="square" tIns="0">
-            <a:spAutoFit/>
-          </a:bodyPr>
-          <a:lstStyle/>
-          <a:p>
-            <a:pPr indent="0" lvl="0" marL="0" marR="0" rtl="0" algn="l">
-              <a:lnSpc>
-                <a:spcPct val="100000"/>
-              </a:lnSpc>
-              <a:spcBef>
-                <a:spcPts val="0"/>
-              </a:spcBef>
-              <a:spcAft>
-                <a:spcPts val="0"/>
-              </a:spcAft>
-              <a:buClr>
-                <a:srgbClr val="000000"/>
-              </a:buClr>
-              <a:buSzPts val="1200"/>
-              <a:buFont typeface="Arial"/>
-              <a:buNone/>
-            </a:pPr>
-            <a:r>
-              <a:rPr b="0" i="0" lang="en-US" sz="1200" u="none" cap="none" strike="noStrike">
-                <a:solidFill>
-                  <a:srgbClr val="0369A1"/>
-                </a:solidFill>
-                <a:latin typeface="Calibri"/>
-                <a:ea typeface="Calibri"/>
-                <a:cs typeface="Calibri"/>
-                <a:sym typeface="Calibri"/>
-              </a:rPr>
-              <a:t>docs.opensearch.org/latest/search-plugins/search-relevance/relevance-agent/</a:t>
-            </a:r>
-            <a:endParaRPr b="0" i="0" sz="1400" u="none" cap="none" strike="noStrike">
-              <a:solidFill>
-                <a:srgbClr val="000000"/>
-              </a:solidFill>
-              <a:latin typeface="Arial"/>
-              <a:ea typeface="Arial"/>
-              <a:cs typeface="Arial"/>
-              <a:sym typeface="Arial"/>
-            </a:endParaRPr>
-          </a:p>
-        </p:txBody>
-      </p:sp>
-      <p:sp>
-        <p:nvSpPr>
-          <p:cNvPr id="311" name="Google Shape;311;p24"/>
-          <p:cNvSpPr txBox="1"/>
-          <p:nvPr/>
-        </p:nvSpPr>
-        <p:spPr>
-          <a:xfrm>
-            <a:off x="457200" y="5294375"/>
-            <a:ext cx="4023360" cy="274320"/>
-          </a:xfrm>
-          <a:prstGeom prst="rect">
-            <a:avLst/>
-          </a:prstGeom>
-          <a:noFill/>
-          <a:ln>
-            <a:noFill/>
-          </a:ln>
-        </p:spPr>
-        <p:txBody>
-          <a:bodyPr anchorCtr="0" anchor="t" bIns="0" lIns="0" spcFirstLastPara="1" rIns="0" wrap="square" tIns="0">
-            <a:spAutoFit/>
-          </a:bodyPr>
-          <a:lstStyle/>
-          <a:p>
-            <a:pPr indent="0" lvl="0" marL="0" marR="0" rtl="0" algn="l">
-              <a:lnSpc>
-                <a:spcPct val="100000"/>
-              </a:lnSpc>
-              <a:spcBef>
-                <a:spcPts val="0"/>
-              </a:spcBef>
-              <a:spcAft>
-                <a:spcPts val="0"/>
-              </a:spcAft>
-              <a:buClr>
-                <a:srgbClr val="000000"/>
-              </a:buClr>
-              <a:buSzPts val="1300"/>
-              <a:buFont typeface="Arial"/>
-              <a:buNone/>
-            </a:pPr>
-            <a:r>
-              <a:rPr b="1" i="0" lang="en-US" sz="1300" u="none" cap="none" strike="noStrike">
-                <a:solidFill>
-                  <a:srgbClr val="0A2540"/>
-                </a:solidFill>
-                <a:latin typeface="Calibri"/>
-                <a:ea typeface="Calibri"/>
-                <a:cs typeface="Calibri"/>
-                <a:sym typeface="Calibri"/>
-              </a:rPr>
-              <a:t>LangGraph evaluator–optimizer workflows</a:t>
-            </a:r>
-            <a:endParaRPr b="0" i="0" sz="1400" u="none" cap="none" strike="noStrike">
-              <a:solidFill>
-                <a:srgbClr val="000000"/>
-              </a:solidFill>
-              <a:latin typeface="Arial"/>
-              <a:ea typeface="Arial"/>
-              <a:cs typeface="Arial"/>
-              <a:sym typeface="Arial"/>
-            </a:endParaRPr>
-          </a:p>
-        </p:txBody>
-      </p:sp>
-      <p:sp>
-        <p:nvSpPr>
-          <p:cNvPr id="312" name="Google Shape;312;p24"/>
-          <p:cNvSpPr txBox="1"/>
-          <p:nvPr/>
-        </p:nvSpPr>
-        <p:spPr>
-          <a:xfrm>
-            <a:off x="4572000" y="5294375"/>
-            <a:ext cx="7223760" cy="274320"/>
-          </a:xfrm>
-          <a:prstGeom prst="rect">
-            <a:avLst/>
-          </a:prstGeom>
-          <a:noFill/>
-          <a:ln>
-            <a:noFill/>
-          </a:ln>
-        </p:spPr>
-        <p:txBody>
-          <a:bodyPr anchorCtr="0" anchor="t" bIns="0" lIns="0" spcFirstLastPara="1" rIns="0" wrap="square" tIns="0">
-            <a:spAutoFit/>
-          </a:bodyPr>
-          <a:lstStyle/>
-          <a:p>
-            <a:pPr indent="0" lvl="0" marL="0" marR="0" rtl="0" algn="l">
-              <a:lnSpc>
-                <a:spcPct val="100000"/>
-              </a:lnSpc>
-              <a:spcBef>
-                <a:spcPts val="0"/>
-              </a:spcBef>
-              <a:spcAft>
-                <a:spcPts val="0"/>
-              </a:spcAft>
-              <a:buClr>
-                <a:srgbClr val="000000"/>
-              </a:buClr>
-              <a:buSzPts val="1200"/>
-              <a:buFont typeface="Arial"/>
-              <a:buNone/>
-            </a:pPr>
-            <a:r>
-              <a:rPr b="0" i="0" lang="en-US" sz="1200" u="none" cap="none" strike="noStrike">
-                <a:solidFill>
-                  <a:srgbClr val="0369A1"/>
-                </a:solidFill>
-                <a:latin typeface="Calibri"/>
-                <a:ea typeface="Calibri"/>
-                <a:cs typeface="Calibri"/>
-                <a:sym typeface="Calibri"/>
-              </a:rPr>
-              <a:t>docs.langchain.com/oss/python/langgraph/workflows-agents</a:t>
-            </a:r>
-            <a:endParaRPr b="0" i="0" sz="1400" u="none" cap="none" strike="noStrike">
-              <a:solidFill>
-                <a:srgbClr val="000000"/>
-              </a:solidFill>
-              <a:latin typeface="Arial"/>
-              <a:ea typeface="Arial"/>
-              <a:cs typeface="Arial"/>
-              <a:sym typeface="Arial"/>
-            </a:endParaRPr>
-          </a:p>
-        </p:txBody>
-      </p:sp>
-      <p:sp>
-        <p:nvSpPr>
-          <p:cNvPr id="313" name="Google Shape;313;p24"/>
-          <p:cNvSpPr txBox="1"/>
-          <p:nvPr/>
-        </p:nvSpPr>
-        <p:spPr>
-          <a:xfrm>
-            <a:off x="457200" y="5769863"/>
-            <a:ext cx="4023360" cy="274320"/>
-          </a:xfrm>
-          <a:prstGeom prst="rect">
-            <a:avLst/>
-          </a:prstGeom>
-          <a:noFill/>
-          <a:ln>
-            <a:noFill/>
-          </a:ln>
-        </p:spPr>
-        <p:txBody>
-          <a:bodyPr anchorCtr="0" anchor="t" bIns="0" lIns="0" spcFirstLastPara="1" rIns="0" wrap="square" tIns="0">
-            <a:spAutoFit/>
-          </a:bodyPr>
-          <a:lstStyle/>
-          <a:p>
-            <a:pPr indent="0" lvl="0" marL="0" marR="0" rtl="0" algn="l">
-              <a:lnSpc>
-                <a:spcPct val="100000"/>
-              </a:lnSpc>
-              <a:spcBef>
-                <a:spcPts val="0"/>
-              </a:spcBef>
-              <a:spcAft>
-                <a:spcPts val="0"/>
-              </a:spcAft>
-              <a:buClr>
-                <a:srgbClr val="000000"/>
-              </a:buClr>
-              <a:buSzPts val="1300"/>
-              <a:buFont typeface="Arial"/>
-              <a:buNone/>
-            </a:pPr>
-            <a:r>
-              <a:rPr b="1" i="0" lang="en-US" sz="1300" u="none" cap="none" strike="noStrike">
-                <a:solidFill>
-                  <a:srgbClr val="0A2540"/>
-                </a:solidFill>
-                <a:latin typeface="Calibri"/>
-                <a:ea typeface="Calibri"/>
-                <a:cs typeface="Calibri"/>
-                <a:sym typeface="Calibri"/>
-              </a:rPr>
-              <a:t>GitHub repository</a:t>
-            </a:r>
-            <a:endParaRPr b="0" i="0" sz="1400" u="none" cap="none" strike="noStrike">
-              <a:solidFill>
-                <a:srgbClr val="000000"/>
-              </a:solidFill>
-              <a:latin typeface="Arial"/>
-              <a:ea typeface="Arial"/>
-              <a:cs typeface="Arial"/>
-              <a:sym typeface="Arial"/>
-            </a:endParaRPr>
-          </a:p>
-        </p:txBody>
-      </p:sp>
-      <p:sp>
-        <p:nvSpPr>
-          <p:cNvPr id="314" name="Google Shape;314;p24"/>
-          <p:cNvSpPr txBox="1"/>
-          <p:nvPr/>
-        </p:nvSpPr>
-        <p:spPr>
-          <a:xfrm>
-            <a:off x="4572000" y="5769863"/>
-            <a:ext cx="7223760" cy="274320"/>
-          </a:xfrm>
-          <a:prstGeom prst="rect">
-            <a:avLst/>
-          </a:prstGeom>
-          <a:noFill/>
-          <a:ln>
-            <a:noFill/>
-          </a:ln>
-        </p:spPr>
-        <p:txBody>
-          <a:bodyPr anchorCtr="0" anchor="t" bIns="0" lIns="0" spcFirstLastPara="1" rIns="0" wrap="square" tIns="0">
-            <a:spAutoFit/>
-          </a:bodyPr>
-          <a:lstStyle/>
-          <a:p>
-            <a:pPr indent="0" lvl="0" marL="0" marR="0" rtl="0" algn="l">
-              <a:lnSpc>
-                <a:spcPct val="100000"/>
-              </a:lnSpc>
-              <a:spcBef>
-                <a:spcPts val="0"/>
-              </a:spcBef>
-              <a:spcAft>
-                <a:spcPts val="0"/>
-              </a:spcAft>
-              <a:buClr>
-                <a:srgbClr val="000000"/>
-              </a:buClr>
-              <a:buSzPts val="1200"/>
-              <a:buFont typeface="Arial"/>
-              <a:buNone/>
-            </a:pPr>
-            <a:r>
-              <a:rPr b="0" i="0" lang="en-US" sz="1200" u="none" cap="none" strike="noStrike">
-                <a:solidFill>
-                  <a:srgbClr val="0369A1"/>
-                </a:solidFill>
-                <a:latin typeface="Calibri"/>
-                <a:ea typeface="Calibri"/>
-                <a:cs typeface="Calibri"/>
-                <a:sym typeface="Calibri"/>
-              </a:rPr>
-              <a:t>github.com/kmwtechnology/opensearch2026-agentic-search</a:t>
-            </a:r>
-            <a:endParaRPr b="0" i="0" sz="1400" u="none" cap="none" strike="noStrike">
-              <a:solidFill>
-                <a:srgbClr val="000000"/>
-              </a:solidFill>
-              <a:latin typeface="Arial"/>
-              <a:ea typeface="Arial"/>
-              <a:cs typeface="Arial"/>
-              <a:sym typeface="Arial"/>
-            </a:endParaRPr>
-          </a:p>
-        </p:txBody>
-      </p:sp>
-      <p:pic>
-        <p:nvPicPr>
-          <p:cNvPr id="315" name="Google Shape;315;p24" title="KMWLogo_blk_blue.png"/>
-          <p:cNvPicPr preferRelativeResize="0"/>
-          <p:nvPr/>
-        </p:nvPicPr>
-        <p:blipFill>
-          <a:blip r:embed="rId3">
-            <a:alphaModFix/>
-          </a:blip>
-          <a:stretch>
-            <a:fillRect/>
-          </a:stretch>
-        </p:blipFill>
-        <p:spPr>
-          <a:xfrm>
-            <a:off x="10059924" y="314175"/>
-            <a:ext cx="1644399" cy="645950"/>
-          </a:xfrm>
-          <a:prstGeom prst="rect">
-            <a:avLst/>
-          </a:prstGeom>
-          <a:noFill/>
-          <a:ln>
-            <a:noFill/>
-          </a:ln>
-        </p:spPr>
-      </p:pic>
-    </p:spTree>
-  </p:cSld>
-  <p:clrMapOvr>
-    <a:masterClrMapping/>
-  </p:clrMapOvr>
-</p:sld>
-</file>
-
-<file path=ppt/slides/slide12.xml><?xml version="1.0" encoding="utf-8"?>
-<p:sld xmlns:a="http://schemas.openxmlformats.org/drawingml/2006/main" xmlns:r="http://schemas.openxmlformats.org/officeDocument/2006/relationships" xmlns:mc="http://schemas.openxmlformats.org/markup-compatibility/2006" xmlns:mv="urn:schemas-microsoft-com:mac:vml" xmlns:p="http://schemas.openxmlformats.org/presentationml/2006/main" xmlns:c="http://schemas.openxmlformats.org/drawingml/2006/chart" xmlns:dgm="http://schemas.openxmlformats.org/drawingml/2006/diagram" xmlns:o="urn:schemas-microsoft-com:office:office" xmlns:v="urn:schemas-microsoft-com:vml" xmlns:pvml="urn:schemas-microsoft-com:office:powerpoint" xmlns:com="http://schemas.openxmlformats.org/drawingml/2006/compatibility" xmlns:p14="http://schemas.microsoft.com/office/powerpoint/2010/main" xmlns:p15="http://schemas.microsoft.com/office/powerpoint/2012/main" xmlns:ahyp="http://schemas.microsoft.com/office/drawing/2018/hyperlinkcolor">
-  <p:cSld>
-    <p:bg>
-      <p:bgPr>
-        <a:solidFill>
-          <a:srgbClr val="0A2540"/>
-        </a:solidFill>
-      </p:bgPr>
-    </p:bg>
-    <p:spTree>
-      <p:nvGrpSpPr>
-        <p:cNvPr id="319" name="Shape 319"/>
-        <p:cNvGrpSpPr/>
-        <p:nvPr/>
-      </p:nvGrpSpPr>
-      <p:grpSpPr>
-        <a:xfrm>
-          <a:off x="0" y="0"/>
-          <a:ext cx="0" cy="0"/>
-          <a:chOff x="0" y="0"/>
-          <a:chExt cx="0" cy="0"/>
-        </a:xfrm>
-      </p:grpSpPr>
-      <p:sp>
-        <p:nvSpPr>
-          <p:cNvPr id="320" name="Google Shape;320;p25"/>
           <p:cNvSpPr/>
           <p:nvPr/>
         </p:nvSpPr>
@@ -18631,14 +17095,14 @@
       </p:sp>
       <p:sp>
         <p:nvSpPr>
-          <p:cNvPr id="321" name="Google Shape;321;p25"/>
+          <p:cNvPr id="294" name="Google Shape;294;p24"/>
           <p:cNvSpPr txBox="1"/>
           <p:nvPr/>
         </p:nvSpPr>
         <p:spPr>
           <a:xfrm>
             <a:off x="640080" y="1952915"/>
-            <a:ext cx="11247000" cy="231000"/>
+            <a:ext cx="11247000" cy="338700"/>
           </a:xfrm>
           <a:prstGeom prst="rect">
             <a:avLst/>
@@ -18672,7 +17136,7 @@
               <a:buNone/>
             </a:pPr>
             <a:r>
-              <a:rPr b="1" i="0" lang="en-US" sz="1500" u="none" cap="none" strike="noStrike">
+              <a:rPr b="1" i="0" lang="en-US" sz="2200" u="none" cap="none" strike="noStrike">
                 <a:solidFill>
                   <a:srgbClr val="0EA5E9"/>
                 </a:solidFill>
@@ -18683,7 +17147,7 @@
               </a:rPr>
               <a:t>THANK YOU</a:t>
             </a:r>
-            <a:endParaRPr b="0" i="0" sz="1400" u="none" cap="none" strike="noStrike">
+            <a:endParaRPr b="0" i="0" sz="2100" u="none" cap="none" strike="noStrike">
               <a:solidFill>
                 <a:srgbClr val="000000"/>
               </a:solidFill>
@@ -18697,13 +17161,13 @@
       </p:sp>
       <p:sp>
         <p:nvSpPr>
-          <p:cNvPr id="322" name="Google Shape;322;p25"/>
+          <p:cNvPr id="295" name="Google Shape;295;p24"/>
           <p:cNvSpPr txBox="1"/>
           <p:nvPr/>
         </p:nvSpPr>
         <p:spPr>
           <a:xfrm>
-            <a:off x="640080" y="2212065"/>
+            <a:off x="609455" y="2390878"/>
             <a:ext cx="11247000" cy="985200"/>
           </a:xfrm>
           <a:prstGeom prst="rect">
@@ -18761,273 +17225,9 @@
           </a:p>
         </p:txBody>
       </p:sp>
-      <p:sp>
-        <p:nvSpPr>
-          <p:cNvPr id="323" name="Google Shape;323;p25"/>
-          <p:cNvSpPr txBox="1"/>
-          <p:nvPr/>
-        </p:nvSpPr>
-        <p:spPr>
-          <a:xfrm>
-            <a:off x="640080" y="3657600"/>
-            <a:ext cx="6400800" cy="274320"/>
-          </a:xfrm>
-          <a:prstGeom prst="rect">
-            <a:avLst/>
-          </a:prstGeom>
-          <a:noFill/>
-          <a:ln>
-            <a:noFill/>
-          </a:ln>
-        </p:spPr>
-        <p:txBody>
-          <a:bodyPr anchorCtr="0" anchor="t" bIns="0" lIns="0" spcFirstLastPara="1" rIns="0" wrap="square" tIns="0">
-            <a:spAutoFit/>
-          </a:bodyPr>
-          <a:lstStyle/>
-          <a:p>
-            <a:pPr indent="0" lvl="0" marL="0" marR="0" rtl="0" algn="l">
-              <a:lnSpc>
-                <a:spcPct val="100000"/>
-              </a:lnSpc>
-              <a:spcBef>
-                <a:spcPts val="0"/>
-              </a:spcBef>
-              <a:spcAft>
-                <a:spcPts val="0"/>
-              </a:spcAft>
-              <a:buClr>
-                <a:srgbClr val="000000"/>
-              </a:buClr>
-              <a:buSzPts val="1000"/>
-              <a:buFont typeface="Arial"/>
-              <a:buNone/>
-            </a:pPr>
-            <a:r>
-              <a:rPr b="1" i="0" lang="en-US" sz="1000" u="none" cap="none" strike="noStrike">
-                <a:solidFill>
-                  <a:srgbClr val="0EA5E9"/>
-                </a:solidFill>
-                <a:latin typeface="Calibri"/>
-                <a:ea typeface="Calibri"/>
-                <a:cs typeface="Calibri"/>
-                <a:sym typeface="Calibri"/>
-              </a:rPr>
-              <a:t>REPO</a:t>
-            </a:r>
-            <a:endParaRPr b="0" i="0" sz="1400" u="none" cap="none" strike="noStrike">
-              <a:solidFill>
-                <a:srgbClr val="000000"/>
-              </a:solidFill>
-              <a:latin typeface="Arial"/>
-              <a:ea typeface="Arial"/>
-              <a:cs typeface="Arial"/>
-              <a:sym typeface="Arial"/>
-            </a:endParaRPr>
-          </a:p>
-        </p:txBody>
-      </p:sp>
-      <p:sp>
-        <p:nvSpPr>
-          <p:cNvPr id="324" name="Google Shape;324;p25"/>
-          <p:cNvSpPr txBox="1"/>
-          <p:nvPr/>
-        </p:nvSpPr>
-        <p:spPr>
-          <a:xfrm>
-            <a:off x="640080" y="3931920"/>
-            <a:ext cx="7772400" cy="365760"/>
-          </a:xfrm>
-          <a:prstGeom prst="rect">
-            <a:avLst/>
-          </a:prstGeom>
-          <a:noFill/>
-          <a:ln>
-            <a:noFill/>
-          </a:ln>
-        </p:spPr>
-        <p:txBody>
-          <a:bodyPr anchorCtr="0" anchor="t" bIns="0" lIns="0" spcFirstLastPara="1" rIns="0" wrap="square" tIns="0">
-            <a:spAutoFit/>
-          </a:bodyPr>
-          <a:lstStyle/>
-          <a:p>
-            <a:pPr indent="0" lvl="0" marL="0" marR="0" rtl="0" algn="l">
-              <a:lnSpc>
-                <a:spcPct val="100000"/>
-              </a:lnSpc>
-              <a:spcBef>
-                <a:spcPts val="0"/>
-              </a:spcBef>
-              <a:spcAft>
-                <a:spcPts val="0"/>
-              </a:spcAft>
-              <a:buClr>
-                <a:srgbClr val="000000"/>
-              </a:buClr>
-              <a:buSzPts val="1600"/>
-              <a:buFont typeface="Arial"/>
-              <a:buNone/>
-            </a:pPr>
-            <a:r>
-              <a:rPr b="1" i="0" lang="en-US" sz="1600" u="none" cap="none" strike="noStrike">
-                <a:solidFill>
-                  <a:srgbClr val="FFFFFF"/>
-                </a:solidFill>
-                <a:latin typeface="Calibri"/>
-                <a:ea typeface="Calibri"/>
-                <a:cs typeface="Calibri"/>
-                <a:sym typeface="Calibri"/>
-              </a:rPr>
-              <a:t>github.com/kmwtechnology/opensearch2026-agentic-search</a:t>
-            </a:r>
-            <a:endParaRPr b="0" i="0" sz="1400" u="none" cap="none" strike="noStrike">
-              <a:solidFill>
-                <a:srgbClr val="000000"/>
-              </a:solidFill>
-              <a:latin typeface="Arial"/>
-              <a:ea typeface="Arial"/>
-              <a:cs typeface="Arial"/>
-              <a:sym typeface="Arial"/>
-            </a:endParaRPr>
-          </a:p>
-        </p:txBody>
-      </p:sp>
-      <p:sp>
-        <p:nvSpPr>
-          <p:cNvPr id="325" name="Google Shape;325;p25"/>
-          <p:cNvSpPr txBox="1"/>
-          <p:nvPr/>
-        </p:nvSpPr>
-        <p:spPr>
-          <a:xfrm>
-            <a:off x="640080" y="4526280"/>
-            <a:ext cx="6400800" cy="274320"/>
-          </a:xfrm>
-          <a:prstGeom prst="rect">
-            <a:avLst/>
-          </a:prstGeom>
-          <a:noFill/>
-          <a:ln>
-            <a:noFill/>
-          </a:ln>
-        </p:spPr>
-        <p:txBody>
-          <a:bodyPr anchorCtr="0" anchor="t" bIns="0" lIns="0" spcFirstLastPara="1" rIns="0" wrap="square" tIns="0">
-            <a:spAutoFit/>
-          </a:bodyPr>
-          <a:lstStyle/>
-          <a:p>
-            <a:pPr indent="0" lvl="0" marL="0" marR="0" rtl="0" algn="l">
-              <a:lnSpc>
-                <a:spcPct val="100000"/>
-              </a:lnSpc>
-              <a:spcBef>
-                <a:spcPts val="0"/>
-              </a:spcBef>
-              <a:spcAft>
-                <a:spcPts val="0"/>
-              </a:spcAft>
-              <a:buClr>
-                <a:srgbClr val="000000"/>
-              </a:buClr>
-              <a:buSzPts val="1000"/>
-              <a:buFont typeface="Arial"/>
-              <a:buNone/>
-            </a:pPr>
-            <a:r>
-              <a:rPr b="1" i="0" lang="en-US" sz="1000" u="none" cap="none" strike="noStrike">
-                <a:solidFill>
-                  <a:srgbClr val="0EA5E9"/>
-                </a:solidFill>
-                <a:latin typeface="Calibri"/>
-                <a:ea typeface="Calibri"/>
-                <a:cs typeface="Calibri"/>
-                <a:sym typeface="Calibri"/>
-              </a:rPr>
-              <a:t>DATASET</a:t>
-            </a:r>
-            <a:endParaRPr b="0" i="0" sz="1400" u="none" cap="none" strike="noStrike">
-              <a:solidFill>
-                <a:srgbClr val="000000"/>
-              </a:solidFill>
-              <a:latin typeface="Arial"/>
-              <a:ea typeface="Arial"/>
-              <a:cs typeface="Arial"/>
-              <a:sym typeface="Arial"/>
-            </a:endParaRPr>
-          </a:p>
-        </p:txBody>
-      </p:sp>
-      <p:sp>
-        <p:nvSpPr>
-          <p:cNvPr id="326" name="Google Shape;326;p25"/>
-          <p:cNvSpPr txBox="1"/>
-          <p:nvPr/>
-        </p:nvSpPr>
-        <p:spPr>
-          <a:xfrm>
-            <a:off x="640080" y="4800600"/>
-            <a:ext cx="6858000" cy="365760"/>
-          </a:xfrm>
-          <a:prstGeom prst="rect">
-            <a:avLst/>
-          </a:prstGeom>
-          <a:noFill/>
-          <a:ln>
-            <a:noFill/>
-          </a:ln>
-        </p:spPr>
-        <p:txBody>
-          <a:bodyPr anchorCtr="0" anchor="t" bIns="0" lIns="0" spcFirstLastPara="1" rIns="0" wrap="square" tIns="0">
-            <a:spAutoFit/>
-          </a:bodyPr>
-          <a:lstStyle/>
-          <a:p>
-            <a:pPr indent="0" lvl="0" marL="0" marR="0" rtl="0" algn="l">
-              <a:lnSpc>
-                <a:spcPct val="100000"/>
-              </a:lnSpc>
-              <a:spcBef>
-                <a:spcPts val="0"/>
-              </a:spcBef>
-              <a:spcAft>
-                <a:spcPts val="0"/>
-              </a:spcAft>
-              <a:buClr>
-                <a:srgbClr val="000000"/>
-              </a:buClr>
-              <a:buSzPts val="1600"/>
-              <a:buFont typeface="Arial"/>
-              <a:buNone/>
-            </a:pPr>
-            <a:r>
-              <a:rPr b="1" i="0" lang="en-US" sz="1600" u="none" cap="none" strike="noStrike">
-                <a:solidFill>
-                  <a:srgbClr val="FFFFFF"/>
-                </a:solidFill>
-                <a:latin typeface="Calibri"/>
-                <a:ea typeface="Calibri"/>
-                <a:cs typeface="Calibri"/>
-                <a:sym typeface="Calibri"/>
-              </a:rPr>
-              <a:t>github.com/amazon-science/esci-data</a:t>
-            </a:r>
-            <a:endParaRPr b="0" i="0" sz="1400" u="none" cap="none" strike="noStrike">
-              <a:solidFill>
-                <a:srgbClr val="000000"/>
-              </a:solidFill>
-              <a:latin typeface="Arial"/>
-              <a:ea typeface="Arial"/>
-              <a:cs typeface="Arial"/>
-              <a:sym typeface="Arial"/>
-            </a:endParaRPr>
-          </a:p>
-        </p:txBody>
-      </p:sp>
       <p:pic>
         <p:nvPicPr>
-          <p:cNvPr id="327" name="Google Shape;327;p25" title="KMWLogo_white.png"/>
+          <p:cNvPr id="296" name="Google Shape;296;p24" title="KMWLogo_white.png"/>
           <p:cNvPicPr preferRelativeResize="0"/>
           <p:nvPr/>
         </p:nvPicPr>
@@ -19055,7 +17255,7 @@
       </p:pic>
       <p:sp>
         <p:nvSpPr>
-          <p:cNvPr id="328" name="Google Shape;328;p25"/>
+          <p:cNvPr id="297" name="Google Shape;297;p24"/>
           <p:cNvSpPr txBox="1"/>
           <p:nvPr/>
         </p:nvSpPr>
@@ -19119,6 +17319,1790 @@
           </a:p>
         </p:txBody>
       </p:sp>
+      <p:sp>
+        <p:nvSpPr>
+          <p:cNvPr id="298" name="Google Shape;298;p24"/>
+          <p:cNvSpPr txBox="1"/>
+          <p:nvPr/>
+        </p:nvSpPr>
+        <p:spPr>
+          <a:xfrm>
+            <a:off x="609443" y="3475325"/>
+            <a:ext cx="10972800" cy="461700"/>
+          </a:xfrm>
+          <a:prstGeom prst="rect">
+            <a:avLst/>
+          </a:prstGeom>
+          <a:solidFill>
+            <a:srgbClr val="000000">
+              <a:alpha val="0"/>
+            </a:srgbClr>
+          </a:solidFill>
+          <a:ln>
+            <a:noFill/>
+          </a:ln>
+        </p:spPr>
+        <p:txBody>
+          <a:bodyPr anchorCtr="0" anchor="ctr" bIns="0" lIns="0" spcFirstLastPara="1" rIns="0" wrap="square" tIns="0">
+            <a:spAutoFit/>
+          </a:bodyPr>
+          <a:lstStyle/>
+          <a:p>
+            <a:pPr indent="0" lvl="0" marL="0" rtl="0" algn="l">
+              <a:spcBef>
+                <a:spcPts val="0"/>
+              </a:spcBef>
+              <a:spcAft>
+                <a:spcPts val="0"/>
+              </a:spcAft>
+              <a:buNone/>
+            </a:pPr>
+            <a:r>
+              <a:rPr b="1" lang="en-US" sz="3000">
+                <a:solidFill>
+                  <a:srgbClr val="FFFFFF"/>
+                </a:solidFill>
+                <a:latin typeface="Calibri"/>
+                <a:ea typeface="Calibri"/>
+                <a:cs typeface="Calibri"/>
+                <a:sym typeface="Calibri"/>
+              </a:rPr>
+              <a:t>Reimagining search from ingestion to relevancy</a:t>
+            </a:r>
+            <a:endParaRPr b="1" sz="3000">
+              <a:solidFill>
+                <a:srgbClr val="FFFFFF"/>
+              </a:solidFill>
+              <a:latin typeface="Calibri"/>
+              <a:ea typeface="Calibri"/>
+              <a:cs typeface="Calibri"/>
+              <a:sym typeface="Calibri"/>
+            </a:endParaRPr>
+          </a:p>
+        </p:txBody>
+      </p:sp>
+      <p:sp>
+        <p:nvSpPr>
+          <p:cNvPr id="299" name="Google Shape;299;p24"/>
+          <p:cNvSpPr txBox="1"/>
+          <p:nvPr/>
+        </p:nvSpPr>
+        <p:spPr>
+          <a:xfrm>
+            <a:off x="609443" y="4237325"/>
+            <a:ext cx="10972800" cy="246300"/>
+          </a:xfrm>
+          <a:prstGeom prst="rect">
+            <a:avLst/>
+          </a:prstGeom>
+          <a:solidFill>
+            <a:srgbClr val="000000">
+              <a:alpha val="0"/>
+            </a:srgbClr>
+          </a:solidFill>
+          <a:ln>
+            <a:noFill/>
+          </a:ln>
+        </p:spPr>
+        <p:txBody>
+          <a:bodyPr anchorCtr="0" anchor="ctr" bIns="0" lIns="0" spcFirstLastPara="1" rIns="0" wrap="square" tIns="0">
+            <a:spAutoFit/>
+          </a:bodyPr>
+          <a:lstStyle/>
+          <a:p>
+            <a:pPr indent="0" lvl="0" marL="0" rtl="0" algn="l">
+              <a:spcBef>
+                <a:spcPts val="0"/>
+              </a:spcBef>
+              <a:spcAft>
+                <a:spcPts val="0"/>
+              </a:spcAft>
+              <a:buNone/>
+            </a:pPr>
+            <a:r>
+              <a:rPr b="0" lang="en-US" sz="1600">
+                <a:solidFill>
+                  <a:srgbClr val="7DD3FC"/>
+                </a:solidFill>
+                <a:latin typeface="Calibri"/>
+                <a:ea typeface="Calibri"/>
+                <a:cs typeface="Calibri"/>
+                <a:sym typeface="Calibri"/>
+              </a:rPr>
+              <a:t>One live LangGraph agent — adaptive retrieval, real ESCI-judged proof, and a catalog it fixes live.</a:t>
+            </a:r>
+            <a:endParaRPr b="0" sz="1600">
+              <a:solidFill>
+                <a:srgbClr val="7DD3FC"/>
+              </a:solidFill>
+              <a:latin typeface="Calibri"/>
+              <a:ea typeface="Calibri"/>
+              <a:cs typeface="Calibri"/>
+              <a:sym typeface="Calibri"/>
+            </a:endParaRPr>
+          </a:p>
+        </p:txBody>
+      </p:sp>
+      <p:sp>
+        <p:nvSpPr>
+          <p:cNvPr id="300" name="Google Shape;300;p24"/>
+          <p:cNvSpPr txBox="1"/>
+          <p:nvPr/>
+        </p:nvSpPr>
+        <p:spPr>
+          <a:xfrm>
+            <a:off x="609443" y="5142200"/>
+            <a:ext cx="10972800" cy="277200"/>
+          </a:xfrm>
+          <a:prstGeom prst="rect">
+            <a:avLst/>
+          </a:prstGeom>
+          <a:solidFill>
+            <a:srgbClr val="000000">
+              <a:alpha val="0"/>
+            </a:srgbClr>
+          </a:solidFill>
+          <a:ln>
+            <a:noFill/>
+          </a:ln>
+        </p:spPr>
+        <p:txBody>
+          <a:bodyPr anchorCtr="0" anchor="ctr" bIns="0" lIns="0" spcFirstLastPara="1" rIns="0" wrap="square" tIns="0">
+            <a:spAutoFit/>
+          </a:bodyPr>
+          <a:lstStyle/>
+          <a:p>
+            <a:pPr indent="0" lvl="0" marL="0" rtl="0" algn="l">
+              <a:spcBef>
+                <a:spcPts val="0"/>
+              </a:spcBef>
+              <a:spcAft>
+                <a:spcPts val="0"/>
+              </a:spcAft>
+              <a:buNone/>
+            </a:pPr>
+            <a:r>
+              <a:rPr b="1" lang="en-US" sz="1800">
+                <a:solidFill>
+                  <a:srgbClr val="FFFFFF"/>
+                </a:solidFill>
+                <a:latin typeface="Calibri"/>
+                <a:ea typeface="Calibri"/>
+                <a:cs typeface="Calibri"/>
+                <a:sym typeface="Calibri"/>
+              </a:rPr>
+              <a:t>Kevin M. Butler</a:t>
+            </a:r>
+            <a:endParaRPr b="1" sz="1800">
+              <a:solidFill>
+                <a:srgbClr val="FFFFFF"/>
+              </a:solidFill>
+              <a:latin typeface="Calibri"/>
+              <a:ea typeface="Calibri"/>
+              <a:cs typeface="Calibri"/>
+              <a:sym typeface="Calibri"/>
+            </a:endParaRPr>
+          </a:p>
+        </p:txBody>
+      </p:sp>
+      <p:sp>
+        <p:nvSpPr>
+          <p:cNvPr id="301" name="Google Shape;301;p24"/>
+          <p:cNvSpPr txBox="1"/>
+          <p:nvPr/>
+        </p:nvSpPr>
+        <p:spPr>
+          <a:xfrm>
+            <a:off x="609443" y="5494625"/>
+            <a:ext cx="7315200" cy="215400"/>
+          </a:xfrm>
+          <a:prstGeom prst="rect">
+            <a:avLst/>
+          </a:prstGeom>
+          <a:solidFill>
+            <a:srgbClr val="000000">
+              <a:alpha val="0"/>
+            </a:srgbClr>
+          </a:solidFill>
+          <a:ln>
+            <a:noFill/>
+          </a:ln>
+        </p:spPr>
+        <p:txBody>
+          <a:bodyPr anchorCtr="0" anchor="ctr" bIns="0" lIns="0" spcFirstLastPara="1" rIns="0" wrap="square" tIns="0">
+            <a:spAutoFit/>
+          </a:bodyPr>
+          <a:lstStyle/>
+          <a:p>
+            <a:pPr indent="0" lvl="0" marL="0" rtl="0" algn="l">
+              <a:spcBef>
+                <a:spcPts val="0"/>
+              </a:spcBef>
+              <a:spcAft>
+                <a:spcPts val="0"/>
+              </a:spcAft>
+              <a:buNone/>
+            </a:pPr>
+            <a:r>
+              <a:rPr b="0" lang="en-US" sz="1400">
+                <a:solidFill>
+                  <a:srgbClr val="B8C5D1"/>
+                </a:solidFill>
+                <a:latin typeface="Calibri"/>
+                <a:ea typeface="Calibri"/>
+                <a:cs typeface="Calibri"/>
+                <a:sym typeface="Calibri"/>
+              </a:rPr>
+              <a:t>Senior Search and AI Engineer</a:t>
+            </a:r>
+            <a:endParaRPr b="0" sz="1400">
+              <a:solidFill>
+                <a:srgbClr val="B8C5D1"/>
+              </a:solidFill>
+              <a:latin typeface="Calibri"/>
+              <a:ea typeface="Calibri"/>
+              <a:cs typeface="Calibri"/>
+              <a:sym typeface="Calibri"/>
+            </a:endParaRPr>
+          </a:p>
+        </p:txBody>
+      </p:sp>
+    </p:spTree>
+  </p:cSld>
+  <p:clrMapOvr>
+    <a:masterClrMapping/>
+  </p:clrMapOvr>
+</p:sld>
+</file>
+
+<file path=ppt/slides/slide12.xml><?xml version="1.0" encoding="utf-8"?>
+<p:sld xmlns:a="http://schemas.openxmlformats.org/drawingml/2006/main" xmlns:r="http://schemas.openxmlformats.org/officeDocument/2006/relationships" xmlns:mc="http://schemas.openxmlformats.org/markup-compatibility/2006" xmlns:mv="urn:schemas-microsoft-com:mac:vml" xmlns:p="http://schemas.openxmlformats.org/presentationml/2006/main" xmlns:c="http://schemas.openxmlformats.org/drawingml/2006/chart" xmlns:dgm="http://schemas.openxmlformats.org/drawingml/2006/diagram" xmlns:o="urn:schemas-microsoft-com:office:office" xmlns:v="urn:schemas-microsoft-com:vml" xmlns:pvml="urn:schemas-microsoft-com:office:powerpoint" xmlns:com="http://schemas.openxmlformats.org/drawingml/2006/compatibility" xmlns:p14="http://schemas.microsoft.com/office/powerpoint/2010/main" xmlns:p15="http://schemas.microsoft.com/office/powerpoint/2012/main" xmlns:ahyp="http://schemas.microsoft.com/office/drawing/2018/hyperlinkcolor">
+  <p:cSld>
+    <p:bg>
+      <p:bgPr>
+        <a:solidFill>
+          <a:srgbClr val="FFFFFF"/>
+        </a:solidFill>
+      </p:bgPr>
+    </p:bg>
+    <p:spTree>
+      <p:nvGrpSpPr>
+        <p:cNvPr id="305" name="Shape 305"/>
+        <p:cNvGrpSpPr/>
+        <p:nvPr/>
+      </p:nvGrpSpPr>
+      <p:grpSpPr>
+        <a:xfrm>
+          <a:off x="0" y="0"/>
+          <a:ext cx="0" cy="0"/>
+          <a:chOff x="0" y="0"/>
+          <a:chExt cx="0" cy="0"/>
+        </a:xfrm>
+      </p:grpSpPr>
+      <p:sp>
+        <p:nvSpPr>
+          <p:cNvPr id="306" name="Google Shape;306;p25"/>
+          <p:cNvSpPr txBox="1"/>
+          <p:nvPr/>
+        </p:nvSpPr>
+        <p:spPr>
+          <a:xfrm>
+            <a:off x="365760" y="228600"/>
+            <a:ext cx="1371600" cy="138600"/>
+          </a:xfrm>
+          <a:prstGeom prst="rect">
+            <a:avLst/>
+          </a:prstGeom>
+          <a:noFill/>
+          <a:ln>
+            <a:noFill/>
+          </a:ln>
+        </p:spPr>
+        <p:txBody>
+          <a:bodyPr anchorCtr="0" anchor="t" bIns="0" lIns="0" spcFirstLastPara="1" rIns="0" wrap="square" tIns="0">
+            <a:spAutoFit/>
+          </a:bodyPr>
+          <a:lstStyle/>
+          <a:p>
+            <a:pPr indent="0" lvl="0" marL="0" marR="0" rtl="0" algn="l">
+              <a:lnSpc>
+                <a:spcPct val="100000"/>
+              </a:lnSpc>
+              <a:spcBef>
+                <a:spcPts val="0"/>
+              </a:spcBef>
+              <a:spcAft>
+                <a:spcPts val="0"/>
+              </a:spcAft>
+              <a:buClr>
+                <a:srgbClr val="000000"/>
+              </a:buClr>
+              <a:buSzPts val="900"/>
+              <a:buFont typeface="Arial"/>
+              <a:buNone/>
+            </a:pPr>
+            <a:r>
+              <a:rPr lang="en-US" sz="900">
+                <a:solidFill>
+                  <a:srgbClr val="94A3B8"/>
+                </a:solidFill>
+                <a:latin typeface="Calibri"/>
+                <a:ea typeface="Calibri"/>
+                <a:cs typeface="Calibri"/>
+                <a:sym typeface="Calibri"/>
+              </a:rPr>
+              <a:t>10 </a:t>
+            </a:r>
+            <a:r>
+              <a:rPr b="0" i="0" lang="en-US" sz="900" u="none" cap="none" strike="noStrike">
+                <a:solidFill>
+                  <a:srgbClr val="94A3B8"/>
+                </a:solidFill>
+                <a:latin typeface="Calibri"/>
+                <a:ea typeface="Calibri"/>
+                <a:cs typeface="Calibri"/>
+                <a:sym typeface="Calibri"/>
+              </a:rPr>
+              <a:t>/ </a:t>
+            </a:r>
+            <a:r>
+              <a:rPr lang="en-US" sz="900">
+                <a:solidFill>
+                  <a:srgbClr val="94A3B8"/>
+                </a:solidFill>
+                <a:latin typeface="Calibri"/>
+                <a:ea typeface="Calibri"/>
+                <a:cs typeface="Calibri"/>
+                <a:sym typeface="Calibri"/>
+              </a:rPr>
+              <a:t>11</a:t>
+            </a:r>
+            <a:endParaRPr sz="900">
+              <a:solidFill>
+                <a:srgbClr val="94A3B8"/>
+              </a:solidFill>
+              <a:latin typeface="Calibri"/>
+              <a:ea typeface="Calibri"/>
+              <a:cs typeface="Calibri"/>
+              <a:sym typeface="Calibri"/>
+            </a:endParaRPr>
+          </a:p>
+        </p:txBody>
+      </p:sp>
+      <p:sp>
+        <p:nvSpPr>
+          <p:cNvPr id="307" name="Google Shape;307;p25"/>
+          <p:cNvSpPr txBox="1"/>
+          <p:nvPr/>
+        </p:nvSpPr>
+        <p:spPr>
+          <a:xfrm>
+            <a:off x="1921298" y="6513375"/>
+            <a:ext cx="10058400" cy="138600"/>
+          </a:xfrm>
+          <a:prstGeom prst="rect">
+            <a:avLst/>
+          </a:prstGeom>
+          <a:noFill/>
+          <a:ln>
+            <a:noFill/>
+          </a:ln>
+        </p:spPr>
+        <p:txBody>
+          <a:bodyPr anchorCtr="0" anchor="t" bIns="0" lIns="0" spcFirstLastPara="1" rIns="0" wrap="square" tIns="0">
+            <a:spAutoFit/>
+          </a:bodyPr>
+          <a:lstStyle/>
+          <a:p>
+            <a:pPr indent="0" lvl="0" marL="0" marR="0" rtl="0" algn="r">
+              <a:lnSpc>
+                <a:spcPct val="100000"/>
+              </a:lnSpc>
+              <a:spcBef>
+                <a:spcPts val="0"/>
+              </a:spcBef>
+              <a:spcAft>
+                <a:spcPts val="0"/>
+              </a:spcAft>
+              <a:buClr>
+                <a:srgbClr val="000000"/>
+              </a:buClr>
+              <a:buSzPts val="900"/>
+              <a:buFont typeface="Arial"/>
+              <a:buNone/>
+            </a:pPr>
+            <a:r>
+              <a:rPr b="0" i="0" lang="en-US" sz="900" u="none" cap="none" strike="noStrike">
+                <a:solidFill>
+                  <a:srgbClr val="94A3B8"/>
+                </a:solidFill>
+                <a:latin typeface="Calibri"/>
+                <a:ea typeface="Calibri"/>
+                <a:cs typeface="Calibri"/>
+                <a:sym typeface="Calibri"/>
+              </a:rPr>
+              <a:t>OpenSearchCon NA 2026  ·  Agentic Search: Reimagining Search from Ingestion to Relevancy</a:t>
+            </a:r>
+            <a:endParaRPr b="0" i="0" sz="1400" u="none" cap="none" strike="noStrike">
+              <a:solidFill>
+                <a:srgbClr val="000000"/>
+              </a:solidFill>
+              <a:latin typeface="Arial"/>
+              <a:ea typeface="Arial"/>
+              <a:cs typeface="Arial"/>
+              <a:sym typeface="Arial"/>
+            </a:endParaRPr>
+          </a:p>
+        </p:txBody>
+      </p:sp>
+      <p:sp>
+        <p:nvSpPr>
+          <p:cNvPr id="308" name="Google Shape;308;p25"/>
+          <p:cNvSpPr txBox="1"/>
+          <p:nvPr/>
+        </p:nvSpPr>
+        <p:spPr>
+          <a:xfrm>
+            <a:off x="457200" y="594360"/>
+            <a:ext cx="11247120" cy="292608"/>
+          </a:xfrm>
+          <a:prstGeom prst="rect">
+            <a:avLst/>
+          </a:prstGeom>
+          <a:noFill/>
+          <a:ln>
+            <a:noFill/>
+          </a:ln>
+        </p:spPr>
+        <p:txBody>
+          <a:bodyPr anchorCtr="0" anchor="t" bIns="0" lIns="0" spcFirstLastPara="1" rIns="0" wrap="square" tIns="0">
+            <a:spAutoFit/>
+          </a:bodyPr>
+          <a:lstStyle/>
+          <a:p>
+            <a:pPr indent="0" lvl="0" marL="0" marR="0" rtl="0" algn="l">
+              <a:lnSpc>
+                <a:spcPct val="100000"/>
+              </a:lnSpc>
+              <a:spcBef>
+                <a:spcPts val="0"/>
+              </a:spcBef>
+              <a:spcAft>
+                <a:spcPts val="0"/>
+              </a:spcAft>
+              <a:buClr>
+                <a:srgbClr val="000000"/>
+              </a:buClr>
+              <a:buSzPts val="1200"/>
+              <a:buFont typeface="Arial"/>
+              <a:buNone/>
+            </a:pPr>
+            <a:r>
+              <a:rPr b="1" i="0" lang="en-US" sz="1200" u="none" cap="none" strike="noStrike">
+                <a:solidFill>
+                  <a:srgbClr val="0369A1"/>
+                </a:solidFill>
+                <a:latin typeface="Calibri"/>
+                <a:ea typeface="Calibri"/>
+                <a:cs typeface="Calibri"/>
+                <a:sym typeface="Calibri"/>
+              </a:rPr>
+              <a:t>SOURCES</a:t>
+            </a:r>
+            <a:endParaRPr b="0" i="0" sz="1400" u="none" cap="none" strike="noStrike">
+              <a:solidFill>
+                <a:srgbClr val="000000"/>
+              </a:solidFill>
+              <a:latin typeface="Arial"/>
+              <a:ea typeface="Arial"/>
+              <a:cs typeface="Arial"/>
+              <a:sym typeface="Arial"/>
+            </a:endParaRPr>
+          </a:p>
+        </p:txBody>
+      </p:sp>
+      <p:sp>
+        <p:nvSpPr>
+          <p:cNvPr id="309" name="Google Shape;309;p25"/>
+          <p:cNvSpPr txBox="1"/>
+          <p:nvPr/>
+        </p:nvSpPr>
+        <p:spPr>
+          <a:xfrm>
+            <a:off x="457200" y="960120"/>
+            <a:ext cx="11247120" cy="777240"/>
+          </a:xfrm>
+          <a:prstGeom prst="rect">
+            <a:avLst/>
+          </a:prstGeom>
+          <a:noFill/>
+          <a:ln>
+            <a:noFill/>
+          </a:ln>
+        </p:spPr>
+        <p:txBody>
+          <a:bodyPr anchorCtr="0" anchor="t" bIns="0" lIns="0" spcFirstLastPara="1" rIns="0" wrap="square" tIns="0">
+            <a:spAutoFit/>
+          </a:bodyPr>
+          <a:lstStyle/>
+          <a:p>
+            <a:pPr indent="0" lvl="0" marL="0" marR="0" rtl="0" algn="l">
+              <a:lnSpc>
+                <a:spcPct val="100000"/>
+              </a:lnSpc>
+              <a:spcBef>
+                <a:spcPts val="0"/>
+              </a:spcBef>
+              <a:spcAft>
+                <a:spcPts val="0"/>
+              </a:spcAft>
+              <a:buClr>
+                <a:srgbClr val="000000"/>
+              </a:buClr>
+              <a:buSzPts val="3200"/>
+              <a:buFont typeface="Arial"/>
+              <a:buNone/>
+            </a:pPr>
+            <a:r>
+              <a:rPr b="1" i="0" lang="en-US" sz="3200" u="none" cap="none" strike="noStrike">
+                <a:solidFill>
+                  <a:srgbClr val="0A2540"/>
+                </a:solidFill>
+                <a:latin typeface="Calibri"/>
+                <a:ea typeface="Calibri"/>
+                <a:cs typeface="Calibri"/>
+                <a:sym typeface="Calibri"/>
+              </a:rPr>
+              <a:t>References</a:t>
+            </a:r>
+            <a:endParaRPr b="0" i="0" sz="1400" u="none" cap="none" strike="noStrike">
+              <a:solidFill>
+                <a:srgbClr val="000000"/>
+              </a:solidFill>
+              <a:latin typeface="Arial"/>
+              <a:ea typeface="Arial"/>
+              <a:cs typeface="Arial"/>
+              <a:sym typeface="Arial"/>
+            </a:endParaRPr>
+          </a:p>
+        </p:txBody>
+      </p:sp>
+      <p:sp>
+        <p:nvSpPr>
+          <p:cNvPr id="310" name="Google Shape;310;p25"/>
+          <p:cNvSpPr txBox="1"/>
+          <p:nvPr/>
+        </p:nvSpPr>
+        <p:spPr>
+          <a:xfrm>
+            <a:off x="457200" y="1965960"/>
+            <a:ext cx="4023360" cy="274320"/>
+          </a:xfrm>
+          <a:prstGeom prst="rect">
+            <a:avLst/>
+          </a:prstGeom>
+          <a:noFill/>
+          <a:ln>
+            <a:noFill/>
+          </a:ln>
+        </p:spPr>
+        <p:txBody>
+          <a:bodyPr anchorCtr="0" anchor="t" bIns="0" lIns="0" spcFirstLastPara="1" rIns="0" wrap="square" tIns="0">
+            <a:spAutoFit/>
+          </a:bodyPr>
+          <a:lstStyle/>
+          <a:p>
+            <a:pPr indent="0" lvl="0" marL="0" marR="0" rtl="0" algn="l">
+              <a:lnSpc>
+                <a:spcPct val="100000"/>
+              </a:lnSpc>
+              <a:spcBef>
+                <a:spcPts val="0"/>
+              </a:spcBef>
+              <a:spcAft>
+                <a:spcPts val="0"/>
+              </a:spcAft>
+              <a:buClr>
+                <a:srgbClr val="000000"/>
+              </a:buClr>
+              <a:buSzPts val="1300"/>
+              <a:buFont typeface="Arial"/>
+              <a:buNone/>
+            </a:pPr>
+            <a:r>
+              <a:rPr b="1" i="0" lang="en-US" sz="1300" u="none" cap="none" strike="noStrike">
+                <a:solidFill>
+                  <a:srgbClr val="0A2540"/>
+                </a:solidFill>
+                <a:latin typeface="Calibri"/>
+                <a:ea typeface="Calibri"/>
+                <a:cs typeface="Calibri"/>
+                <a:sym typeface="Calibri"/>
+              </a:rPr>
+              <a:t>Search Relevance Workbench</a:t>
+            </a:r>
+            <a:endParaRPr b="0" i="0" sz="1400" u="none" cap="none" strike="noStrike">
+              <a:solidFill>
+                <a:srgbClr val="000000"/>
+              </a:solidFill>
+              <a:latin typeface="Arial"/>
+              <a:ea typeface="Arial"/>
+              <a:cs typeface="Arial"/>
+              <a:sym typeface="Arial"/>
+            </a:endParaRPr>
+          </a:p>
+        </p:txBody>
+      </p:sp>
+      <p:sp>
+        <p:nvSpPr>
+          <p:cNvPr id="311" name="Google Shape;311;p25"/>
+          <p:cNvSpPr txBox="1"/>
+          <p:nvPr/>
+        </p:nvSpPr>
+        <p:spPr>
+          <a:xfrm>
+            <a:off x="4572000" y="1965960"/>
+            <a:ext cx="7223760" cy="274320"/>
+          </a:xfrm>
+          <a:prstGeom prst="rect">
+            <a:avLst/>
+          </a:prstGeom>
+          <a:noFill/>
+          <a:ln>
+            <a:noFill/>
+          </a:ln>
+        </p:spPr>
+        <p:txBody>
+          <a:bodyPr anchorCtr="0" anchor="t" bIns="0" lIns="0" spcFirstLastPara="1" rIns="0" wrap="square" tIns="0">
+            <a:spAutoFit/>
+          </a:bodyPr>
+          <a:lstStyle/>
+          <a:p>
+            <a:pPr indent="0" lvl="0" marL="0" marR="0" rtl="0" algn="l">
+              <a:lnSpc>
+                <a:spcPct val="100000"/>
+              </a:lnSpc>
+              <a:spcBef>
+                <a:spcPts val="0"/>
+              </a:spcBef>
+              <a:spcAft>
+                <a:spcPts val="0"/>
+              </a:spcAft>
+              <a:buClr>
+                <a:srgbClr val="000000"/>
+              </a:buClr>
+              <a:buSzPts val="1200"/>
+              <a:buFont typeface="Arial"/>
+              <a:buNone/>
+            </a:pPr>
+            <a:r>
+              <a:rPr b="0" i="0" lang="en-US" sz="1200" u="none" cap="none" strike="noStrike">
+                <a:solidFill>
+                  <a:srgbClr val="0369A1"/>
+                </a:solidFill>
+                <a:latin typeface="Calibri"/>
+                <a:ea typeface="Calibri"/>
+                <a:cs typeface="Calibri"/>
+                <a:sym typeface="Calibri"/>
+              </a:rPr>
+              <a:t>docs.opensearch.org/latest/search-plugins/search-relevance/using-search-relevance-workbench/</a:t>
+            </a:r>
+            <a:endParaRPr b="0" i="0" sz="1400" u="none" cap="none" strike="noStrike">
+              <a:solidFill>
+                <a:srgbClr val="000000"/>
+              </a:solidFill>
+              <a:latin typeface="Arial"/>
+              <a:ea typeface="Arial"/>
+              <a:cs typeface="Arial"/>
+              <a:sym typeface="Arial"/>
+            </a:endParaRPr>
+          </a:p>
+        </p:txBody>
+      </p:sp>
+      <p:sp>
+        <p:nvSpPr>
+          <p:cNvPr id="312" name="Google Shape;312;p25"/>
+          <p:cNvSpPr txBox="1"/>
+          <p:nvPr/>
+        </p:nvSpPr>
+        <p:spPr>
+          <a:xfrm>
+            <a:off x="457200" y="2441448"/>
+            <a:ext cx="4023360" cy="274320"/>
+          </a:xfrm>
+          <a:prstGeom prst="rect">
+            <a:avLst/>
+          </a:prstGeom>
+          <a:noFill/>
+          <a:ln>
+            <a:noFill/>
+          </a:ln>
+        </p:spPr>
+        <p:txBody>
+          <a:bodyPr anchorCtr="0" anchor="t" bIns="0" lIns="0" spcFirstLastPara="1" rIns="0" wrap="square" tIns="0">
+            <a:spAutoFit/>
+          </a:bodyPr>
+          <a:lstStyle/>
+          <a:p>
+            <a:pPr indent="0" lvl="0" marL="0" marR="0" rtl="0" algn="l">
+              <a:lnSpc>
+                <a:spcPct val="100000"/>
+              </a:lnSpc>
+              <a:spcBef>
+                <a:spcPts val="0"/>
+              </a:spcBef>
+              <a:spcAft>
+                <a:spcPts val="0"/>
+              </a:spcAft>
+              <a:buClr>
+                <a:srgbClr val="000000"/>
+              </a:buClr>
+              <a:buSzPts val="1300"/>
+              <a:buFont typeface="Arial"/>
+              <a:buNone/>
+            </a:pPr>
+            <a:r>
+              <a:rPr b="1" i="0" lang="en-US" sz="1300" u="none" cap="none" strike="noStrike">
+                <a:solidFill>
+                  <a:srgbClr val="0A2540"/>
+                </a:solidFill>
+                <a:latin typeface="Calibri"/>
+                <a:ea typeface="Calibri"/>
+                <a:cs typeface="Calibri"/>
+                <a:sym typeface="Calibri"/>
+              </a:rPr>
+              <a:t>Judgments</a:t>
+            </a:r>
+            <a:endParaRPr b="0" i="0" sz="1400" u="none" cap="none" strike="noStrike">
+              <a:solidFill>
+                <a:srgbClr val="000000"/>
+              </a:solidFill>
+              <a:latin typeface="Arial"/>
+              <a:ea typeface="Arial"/>
+              <a:cs typeface="Arial"/>
+              <a:sym typeface="Arial"/>
+            </a:endParaRPr>
+          </a:p>
+        </p:txBody>
+      </p:sp>
+      <p:sp>
+        <p:nvSpPr>
+          <p:cNvPr id="313" name="Google Shape;313;p25"/>
+          <p:cNvSpPr txBox="1"/>
+          <p:nvPr/>
+        </p:nvSpPr>
+        <p:spPr>
+          <a:xfrm>
+            <a:off x="4572000" y="2441448"/>
+            <a:ext cx="7223760" cy="274320"/>
+          </a:xfrm>
+          <a:prstGeom prst="rect">
+            <a:avLst/>
+          </a:prstGeom>
+          <a:noFill/>
+          <a:ln>
+            <a:noFill/>
+          </a:ln>
+        </p:spPr>
+        <p:txBody>
+          <a:bodyPr anchorCtr="0" anchor="t" bIns="0" lIns="0" spcFirstLastPara="1" rIns="0" wrap="square" tIns="0">
+            <a:spAutoFit/>
+          </a:bodyPr>
+          <a:lstStyle/>
+          <a:p>
+            <a:pPr indent="0" lvl="0" marL="0" marR="0" rtl="0" algn="l">
+              <a:lnSpc>
+                <a:spcPct val="100000"/>
+              </a:lnSpc>
+              <a:spcBef>
+                <a:spcPts val="0"/>
+              </a:spcBef>
+              <a:spcAft>
+                <a:spcPts val="0"/>
+              </a:spcAft>
+              <a:buClr>
+                <a:srgbClr val="000000"/>
+              </a:buClr>
+              <a:buSzPts val="1200"/>
+              <a:buFont typeface="Arial"/>
+              <a:buNone/>
+            </a:pPr>
+            <a:r>
+              <a:rPr b="0" i="0" lang="en-US" sz="1200" u="none" cap="none" strike="noStrike">
+                <a:solidFill>
+                  <a:srgbClr val="0369A1"/>
+                </a:solidFill>
+                <a:latin typeface="Calibri"/>
+                <a:ea typeface="Calibri"/>
+                <a:cs typeface="Calibri"/>
+                <a:sym typeface="Calibri"/>
+              </a:rPr>
+              <a:t>docs.opensearch.org/latest/search-plugins/search-relevance/judgments/</a:t>
+            </a:r>
+            <a:endParaRPr b="0" i="0" sz="1400" u="none" cap="none" strike="noStrike">
+              <a:solidFill>
+                <a:srgbClr val="000000"/>
+              </a:solidFill>
+              <a:latin typeface="Arial"/>
+              <a:ea typeface="Arial"/>
+              <a:cs typeface="Arial"/>
+              <a:sym typeface="Arial"/>
+            </a:endParaRPr>
+          </a:p>
+        </p:txBody>
+      </p:sp>
+      <p:sp>
+        <p:nvSpPr>
+          <p:cNvPr id="314" name="Google Shape;314;p25"/>
+          <p:cNvSpPr txBox="1"/>
+          <p:nvPr/>
+        </p:nvSpPr>
+        <p:spPr>
+          <a:xfrm>
+            <a:off x="457200" y="2916936"/>
+            <a:ext cx="4023360" cy="274320"/>
+          </a:xfrm>
+          <a:prstGeom prst="rect">
+            <a:avLst/>
+          </a:prstGeom>
+          <a:noFill/>
+          <a:ln>
+            <a:noFill/>
+          </a:ln>
+        </p:spPr>
+        <p:txBody>
+          <a:bodyPr anchorCtr="0" anchor="t" bIns="0" lIns="0" spcFirstLastPara="1" rIns="0" wrap="square" tIns="0">
+            <a:spAutoFit/>
+          </a:bodyPr>
+          <a:lstStyle/>
+          <a:p>
+            <a:pPr indent="0" lvl="0" marL="0" marR="0" rtl="0" algn="l">
+              <a:lnSpc>
+                <a:spcPct val="100000"/>
+              </a:lnSpc>
+              <a:spcBef>
+                <a:spcPts val="0"/>
+              </a:spcBef>
+              <a:spcAft>
+                <a:spcPts val="0"/>
+              </a:spcAft>
+              <a:buClr>
+                <a:srgbClr val="000000"/>
+              </a:buClr>
+              <a:buSzPts val="1300"/>
+              <a:buFont typeface="Arial"/>
+              <a:buNone/>
+            </a:pPr>
+            <a:r>
+              <a:rPr b="1" i="0" lang="en-US" sz="1300" u="none" cap="none" strike="noStrike">
+                <a:solidFill>
+                  <a:srgbClr val="0A2540"/>
+                </a:solidFill>
+                <a:latin typeface="Calibri"/>
+                <a:ea typeface="Calibri"/>
+                <a:cs typeface="Calibri"/>
+                <a:sym typeface="Calibri"/>
+              </a:rPr>
+              <a:t>Evaluating search quality</a:t>
+            </a:r>
+            <a:endParaRPr b="0" i="0" sz="1400" u="none" cap="none" strike="noStrike">
+              <a:solidFill>
+                <a:srgbClr val="000000"/>
+              </a:solidFill>
+              <a:latin typeface="Arial"/>
+              <a:ea typeface="Arial"/>
+              <a:cs typeface="Arial"/>
+              <a:sym typeface="Arial"/>
+            </a:endParaRPr>
+          </a:p>
+        </p:txBody>
+      </p:sp>
+      <p:sp>
+        <p:nvSpPr>
+          <p:cNvPr id="315" name="Google Shape;315;p25"/>
+          <p:cNvSpPr txBox="1"/>
+          <p:nvPr/>
+        </p:nvSpPr>
+        <p:spPr>
+          <a:xfrm>
+            <a:off x="4572000" y="2916936"/>
+            <a:ext cx="7223760" cy="274320"/>
+          </a:xfrm>
+          <a:prstGeom prst="rect">
+            <a:avLst/>
+          </a:prstGeom>
+          <a:noFill/>
+          <a:ln>
+            <a:noFill/>
+          </a:ln>
+        </p:spPr>
+        <p:txBody>
+          <a:bodyPr anchorCtr="0" anchor="t" bIns="0" lIns="0" spcFirstLastPara="1" rIns="0" wrap="square" tIns="0">
+            <a:spAutoFit/>
+          </a:bodyPr>
+          <a:lstStyle/>
+          <a:p>
+            <a:pPr indent="0" lvl="0" marL="0" marR="0" rtl="0" algn="l">
+              <a:lnSpc>
+                <a:spcPct val="100000"/>
+              </a:lnSpc>
+              <a:spcBef>
+                <a:spcPts val="0"/>
+              </a:spcBef>
+              <a:spcAft>
+                <a:spcPts val="0"/>
+              </a:spcAft>
+              <a:buClr>
+                <a:srgbClr val="000000"/>
+              </a:buClr>
+              <a:buSzPts val="1200"/>
+              <a:buFont typeface="Arial"/>
+              <a:buNone/>
+            </a:pPr>
+            <a:r>
+              <a:rPr b="0" i="0" lang="en-US" sz="1200" u="none" cap="none" strike="noStrike">
+                <a:solidFill>
+                  <a:srgbClr val="0369A1"/>
+                </a:solidFill>
+                <a:latin typeface="Calibri"/>
+                <a:ea typeface="Calibri"/>
+                <a:cs typeface="Calibri"/>
+                <a:sym typeface="Calibri"/>
+              </a:rPr>
+              <a:t>docs.opensearch.org/latest/search-plugins/search-relevance/evaluate-search-quality/</a:t>
+            </a:r>
+            <a:endParaRPr b="0" i="0" sz="1400" u="none" cap="none" strike="noStrike">
+              <a:solidFill>
+                <a:srgbClr val="000000"/>
+              </a:solidFill>
+              <a:latin typeface="Arial"/>
+              <a:ea typeface="Arial"/>
+              <a:cs typeface="Arial"/>
+              <a:sym typeface="Arial"/>
+            </a:endParaRPr>
+          </a:p>
+        </p:txBody>
+      </p:sp>
+      <p:sp>
+        <p:nvSpPr>
+          <p:cNvPr id="316" name="Google Shape;316;p25"/>
+          <p:cNvSpPr txBox="1"/>
+          <p:nvPr/>
+        </p:nvSpPr>
+        <p:spPr>
+          <a:xfrm>
+            <a:off x="457200" y="3392424"/>
+            <a:ext cx="4023360" cy="274320"/>
+          </a:xfrm>
+          <a:prstGeom prst="rect">
+            <a:avLst/>
+          </a:prstGeom>
+          <a:noFill/>
+          <a:ln>
+            <a:noFill/>
+          </a:ln>
+        </p:spPr>
+        <p:txBody>
+          <a:bodyPr anchorCtr="0" anchor="t" bIns="0" lIns="0" spcFirstLastPara="1" rIns="0" wrap="square" tIns="0">
+            <a:spAutoFit/>
+          </a:bodyPr>
+          <a:lstStyle/>
+          <a:p>
+            <a:pPr indent="0" lvl="0" marL="0" marR="0" rtl="0" algn="l">
+              <a:lnSpc>
+                <a:spcPct val="100000"/>
+              </a:lnSpc>
+              <a:spcBef>
+                <a:spcPts val="0"/>
+              </a:spcBef>
+              <a:spcAft>
+                <a:spcPts val="0"/>
+              </a:spcAft>
+              <a:buClr>
+                <a:srgbClr val="000000"/>
+              </a:buClr>
+              <a:buSzPts val="1300"/>
+              <a:buFont typeface="Arial"/>
+              <a:buNone/>
+            </a:pPr>
+            <a:r>
+              <a:rPr b="1" i="0" lang="en-US" sz="1300" u="none" cap="none" strike="noStrike">
+                <a:solidFill>
+                  <a:srgbClr val="0A2540"/>
+                </a:solidFill>
+                <a:latin typeface="Calibri"/>
+                <a:ea typeface="Calibri"/>
+                <a:cs typeface="Calibri"/>
+                <a:sym typeface="Calibri"/>
+              </a:rPr>
+              <a:t>Optimizing hybrid search</a:t>
+            </a:r>
+            <a:endParaRPr b="0" i="0" sz="1400" u="none" cap="none" strike="noStrike">
+              <a:solidFill>
+                <a:srgbClr val="000000"/>
+              </a:solidFill>
+              <a:latin typeface="Arial"/>
+              <a:ea typeface="Arial"/>
+              <a:cs typeface="Arial"/>
+              <a:sym typeface="Arial"/>
+            </a:endParaRPr>
+          </a:p>
+        </p:txBody>
+      </p:sp>
+      <p:sp>
+        <p:nvSpPr>
+          <p:cNvPr id="317" name="Google Shape;317;p25"/>
+          <p:cNvSpPr txBox="1"/>
+          <p:nvPr/>
+        </p:nvSpPr>
+        <p:spPr>
+          <a:xfrm>
+            <a:off x="4572000" y="3392424"/>
+            <a:ext cx="7223760" cy="274320"/>
+          </a:xfrm>
+          <a:prstGeom prst="rect">
+            <a:avLst/>
+          </a:prstGeom>
+          <a:noFill/>
+          <a:ln>
+            <a:noFill/>
+          </a:ln>
+        </p:spPr>
+        <p:txBody>
+          <a:bodyPr anchorCtr="0" anchor="t" bIns="0" lIns="0" spcFirstLastPara="1" rIns="0" wrap="square" tIns="0">
+            <a:spAutoFit/>
+          </a:bodyPr>
+          <a:lstStyle/>
+          <a:p>
+            <a:pPr indent="0" lvl="0" marL="0" marR="0" rtl="0" algn="l">
+              <a:lnSpc>
+                <a:spcPct val="100000"/>
+              </a:lnSpc>
+              <a:spcBef>
+                <a:spcPts val="0"/>
+              </a:spcBef>
+              <a:spcAft>
+                <a:spcPts val="0"/>
+              </a:spcAft>
+              <a:buClr>
+                <a:srgbClr val="000000"/>
+              </a:buClr>
+              <a:buSzPts val="1200"/>
+              <a:buFont typeface="Arial"/>
+              <a:buNone/>
+            </a:pPr>
+            <a:r>
+              <a:rPr b="0" i="0" lang="en-US" sz="1200" u="none" cap="none" strike="noStrike">
+                <a:solidFill>
+                  <a:srgbClr val="0369A1"/>
+                </a:solidFill>
+                <a:latin typeface="Calibri"/>
+                <a:ea typeface="Calibri"/>
+                <a:cs typeface="Calibri"/>
+                <a:sym typeface="Calibri"/>
+              </a:rPr>
+              <a:t>docs.opensearch.org/latest/search-plugins/search-relevance/optimize-hybrid-search/</a:t>
+            </a:r>
+            <a:endParaRPr b="0" i="0" sz="1400" u="none" cap="none" strike="noStrike">
+              <a:solidFill>
+                <a:srgbClr val="000000"/>
+              </a:solidFill>
+              <a:latin typeface="Arial"/>
+              <a:ea typeface="Arial"/>
+              <a:cs typeface="Arial"/>
+              <a:sym typeface="Arial"/>
+            </a:endParaRPr>
+          </a:p>
+        </p:txBody>
+      </p:sp>
+      <p:sp>
+        <p:nvSpPr>
+          <p:cNvPr id="318" name="Google Shape;318;p25"/>
+          <p:cNvSpPr txBox="1"/>
+          <p:nvPr/>
+        </p:nvSpPr>
+        <p:spPr>
+          <a:xfrm>
+            <a:off x="457200" y="3867912"/>
+            <a:ext cx="4023360" cy="274320"/>
+          </a:xfrm>
+          <a:prstGeom prst="rect">
+            <a:avLst/>
+          </a:prstGeom>
+          <a:noFill/>
+          <a:ln>
+            <a:noFill/>
+          </a:ln>
+        </p:spPr>
+        <p:txBody>
+          <a:bodyPr anchorCtr="0" anchor="t" bIns="0" lIns="0" spcFirstLastPara="1" rIns="0" wrap="square" tIns="0">
+            <a:spAutoFit/>
+          </a:bodyPr>
+          <a:lstStyle/>
+          <a:p>
+            <a:pPr indent="0" lvl="0" marL="0" marR="0" rtl="0" algn="l">
+              <a:lnSpc>
+                <a:spcPct val="100000"/>
+              </a:lnSpc>
+              <a:spcBef>
+                <a:spcPts val="0"/>
+              </a:spcBef>
+              <a:spcAft>
+                <a:spcPts val="0"/>
+              </a:spcAft>
+              <a:buClr>
+                <a:srgbClr val="000000"/>
+              </a:buClr>
+              <a:buSzPts val="1300"/>
+              <a:buFont typeface="Arial"/>
+              <a:buNone/>
+            </a:pPr>
+            <a:r>
+              <a:rPr b="1" i="0" lang="en-US" sz="1300" u="none" cap="none" strike="noStrike">
+                <a:solidFill>
+                  <a:srgbClr val="0A2540"/>
+                </a:solidFill>
+                <a:latin typeface="Calibri"/>
+                <a:ea typeface="Calibri"/>
+                <a:cs typeface="Calibri"/>
+                <a:sym typeface="Calibri"/>
+              </a:rPr>
+              <a:t>Exploring experiment results</a:t>
+            </a:r>
+            <a:endParaRPr b="0" i="0" sz="1400" u="none" cap="none" strike="noStrike">
+              <a:solidFill>
+                <a:srgbClr val="000000"/>
+              </a:solidFill>
+              <a:latin typeface="Arial"/>
+              <a:ea typeface="Arial"/>
+              <a:cs typeface="Arial"/>
+              <a:sym typeface="Arial"/>
+            </a:endParaRPr>
+          </a:p>
+        </p:txBody>
+      </p:sp>
+      <p:sp>
+        <p:nvSpPr>
+          <p:cNvPr id="319" name="Google Shape;319;p25"/>
+          <p:cNvSpPr txBox="1"/>
+          <p:nvPr/>
+        </p:nvSpPr>
+        <p:spPr>
+          <a:xfrm>
+            <a:off x="4572000" y="3867912"/>
+            <a:ext cx="7223760" cy="274320"/>
+          </a:xfrm>
+          <a:prstGeom prst="rect">
+            <a:avLst/>
+          </a:prstGeom>
+          <a:noFill/>
+          <a:ln>
+            <a:noFill/>
+          </a:ln>
+        </p:spPr>
+        <p:txBody>
+          <a:bodyPr anchorCtr="0" anchor="t" bIns="0" lIns="0" spcFirstLastPara="1" rIns="0" wrap="square" tIns="0">
+            <a:spAutoFit/>
+          </a:bodyPr>
+          <a:lstStyle/>
+          <a:p>
+            <a:pPr indent="0" lvl="0" marL="0" marR="0" rtl="0" algn="l">
+              <a:lnSpc>
+                <a:spcPct val="100000"/>
+              </a:lnSpc>
+              <a:spcBef>
+                <a:spcPts val="0"/>
+              </a:spcBef>
+              <a:spcAft>
+                <a:spcPts val="0"/>
+              </a:spcAft>
+              <a:buClr>
+                <a:srgbClr val="000000"/>
+              </a:buClr>
+              <a:buSzPts val="1200"/>
+              <a:buFont typeface="Arial"/>
+              <a:buNone/>
+            </a:pPr>
+            <a:r>
+              <a:rPr b="0" i="0" lang="en-US" sz="1200" u="none" cap="none" strike="noStrike">
+                <a:solidFill>
+                  <a:srgbClr val="0369A1"/>
+                </a:solidFill>
+                <a:latin typeface="Calibri"/>
+                <a:ea typeface="Calibri"/>
+                <a:cs typeface="Calibri"/>
+                <a:sym typeface="Calibri"/>
+              </a:rPr>
+              <a:t>docs.opensearch.org/latest/search-plugins/search-relevance/explore-experiment-results/</a:t>
+            </a:r>
+            <a:endParaRPr b="0" i="0" sz="1400" u="none" cap="none" strike="noStrike">
+              <a:solidFill>
+                <a:srgbClr val="000000"/>
+              </a:solidFill>
+              <a:latin typeface="Arial"/>
+              <a:ea typeface="Arial"/>
+              <a:cs typeface="Arial"/>
+              <a:sym typeface="Arial"/>
+            </a:endParaRPr>
+          </a:p>
+        </p:txBody>
+      </p:sp>
+      <p:sp>
+        <p:nvSpPr>
+          <p:cNvPr id="320" name="Google Shape;320;p25"/>
+          <p:cNvSpPr txBox="1"/>
+          <p:nvPr/>
+        </p:nvSpPr>
+        <p:spPr>
+          <a:xfrm>
+            <a:off x="457200" y="4343400"/>
+            <a:ext cx="4023360" cy="274320"/>
+          </a:xfrm>
+          <a:prstGeom prst="rect">
+            <a:avLst/>
+          </a:prstGeom>
+          <a:noFill/>
+          <a:ln>
+            <a:noFill/>
+          </a:ln>
+        </p:spPr>
+        <p:txBody>
+          <a:bodyPr anchorCtr="0" anchor="t" bIns="0" lIns="0" spcFirstLastPara="1" rIns="0" wrap="square" tIns="0">
+            <a:spAutoFit/>
+          </a:bodyPr>
+          <a:lstStyle/>
+          <a:p>
+            <a:pPr indent="0" lvl="0" marL="0" marR="0" rtl="0" algn="l">
+              <a:lnSpc>
+                <a:spcPct val="100000"/>
+              </a:lnSpc>
+              <a:spcBef>
+                <a:spcPts val="0"/>
+              </a:spcBef>
+              <a:spcAft>
+                <a:spcPts val="0"/>
+              </a:spcAft>
+              <a:buClr>
+                <a:srgbClr val="000000"/>
+              </a:buClr>
+              <a:buSzPts val="1300"/>
+              <a:buFont typeface="Arial"/>
+              <a:buNone/>
+            </a:pPr>
+            <a:r>
+              <a:rPr b="1" i="0" lang="en-US" sz="1300" u="none" cap="none" strike="noStrike">
+                <a:solidFill>
+                  <a:srgbClr val="0A2540"/>
+                </a:solidFill>
+                <a:latin typeface="Calibri"/>
+                <a:ea typeface="Calibri"/>
+                <a:cs typeface="Calibri"/>
+                <a:sym typeface="Calibri"/>
+              </a:rPr>
+              <a:t>Monitoring search quality</a:t>
+            </a:r>
+            <a:endParaRPr b="0" i="0" sz="1400" u="none" cap="none" strike="noStrike">
+              <a:solidFill>
+                <a:srgbClr val="000000"/>
+              </a:solidFill>
+              <a:latin typeface="Arial"/>
+              <a:ea typeface="Arial"/>
+              <a:cs typeface="Arial"/>
+              <a:sym typeface="Arial"/>
+            </a:endParaRPr>
+          </a:p>
+        </p:txBody>
+      </p:sp>
+      <p:sp>
+        <p:nvSpPr>
+          <p:cNvPr id="321" name="Google Shape;321;p25"/>
+          <p:cNvSpPr txBox="1"/>
+          <p:nvPr/>
+        </p:nvSpPr>
+        <p:spPr>
+          <a:xfrm>
+            <a:off x="4572000" y="4343400"/>
+            <a:ext cx="7223760" cy="274320"/>
+          </a:xfrm>
+          <a:prstGeom prst="rect">
+            <a:avLst/>
+          </a:prstGeom>
+          <a:noFill/>
+          <a:ln>
+            <a:noFill/>
+          </a:ln>
+        </p:spPr>
+        <p:txBody>
+          <a:bodyPr anchorCtr="0" anchor="t" bIns="0" lIns="0" spcFirstLastPara="1" rIns="0" wrap="square" tIns="0">
+            <a:spAutoFit/>
+          </a:bodyPr>
+          <a:lstStyle/>
+          <a:p>
+            <a:pPr indent="0" lvl="0" marL="0" marR="0" rtl="0" algn="l">
+              <a:lnSpc>
+                <a:spcPct val="100000"/>
+              </a:lnSpc>
+              <a:spcBef>
+                <a:spcPts val="0"/>
+              </a:spcBef>
+              <a:spcAft>
+                <a:spcPts val="0"/>
+              </a:spcAft>
+              <a:buClr>
+                <a:srgbClr val="000000"/>
+              </a:buClr>
+              <a:buSzPts val="1200"/>
+              <a:buFont typeface="Arial"/>
+              <a:buNone/>
+            </a:pPr>
+            <a:r>
+              <a:rPr b="0" i="0" lang="en-US" sz="1200" u="none" cap="none" strike="noStrike">
+                <a:solidFill>
+                  <a:srgbClr val="0369A1"/>
+                </a:solidFill>
+                <a:latin typeface="Calibri"/>
+                <a:ea typeface="Calibri"/>
+                <a:cs typeface="Calibri"/>
+                <a:sym typeface="Calibri"/>
+              </a:rPr>
+              <a:t>docs.opensearch.org/latest/search-plugins/search-relevance/regularly-scheduled-experiments/</a:t>
+            </a:r>
+            <a:endParaRPr b="0" i="0" sz="1400" u="none" cap="none" strike="noStrike">
+              <a:solidFill>
+                <a:srgbClr val="000000"/>
+              </a:solidFill>
+              <a:latin typeface="Arial"/>
+              <a:ea typeface="Arial"/>
+              <a:cs typeface="Arial"/>
+              <a:sym typeface="Arial"/>
+            </a:endParaRPr>
+          </a:p>
+        </p:txBody>
+      </p:sp>
+      <p:sp>
+        <p:nvSpPr>
+          <p:cNvPr id="322" name="Google Shape;322;p25"/>
+          <p:cNvSpPr txBox="1"/>
+          <p:nvPr/>
+        </p:nvSpPr>
+        <p:spPr>
+          <a:xfrm>
+            <a:off x="457200" y="4818888"/>
+            <a:ext cx="4023360" cy="274320"/>
+          </a:xfrm>
+          <a:prstGeom prst="rect">
+            <a:avLst/>
+          </a:prstGeom>
+          <a:noFill/>
+          <a:ln>
+            <a:noFill/>
+          </a:ln>
+        </p:spPr>
+        <p:txBody>
+          <a:bodyPr anchorCtr="0" anchor="t" bIns="0" lIns="0" spcFirstLastPara="1" rIns="0" wrap="square" tIns="0">
+            <a:spAutoFit/>
+          </a:bodyPr>
+          <a:lstStyle/>
+          <a:p>
+            <a:pPr indent="0" lvl="0" marL="0" marR="0" rtl="0" algn="l">
+              <a:lnSpc>
+                <a:spcPct val="100000"/>
+              </a:lnSpc>
+              <a:spcBef>
+                <a:spcPts val="0"/>
+              </a:spcBef>
+              <a:spcAft>
+                <a:spcPts val="0"/>
+              </a:spcAft>
+              <a:buClr>
+                <a:srgbClr val="000000"/>
+              </a:buClr>
+              <a:buSzPts val="1300"/>
+              <a:buFont typeface="Arial"/>
+              <a:buNone/>
+            </a:pPr>
+            <a:r>
+              <a:rPr b="1" i="0" lang="en-US" sz="1300" u="none" cap="none" strike="noStrike">
+                <a:solidFill>
+                  <a:srgbClr val="0A2540"/>
+                </a:solidFill>
+                <a:latin typeface="Calibri"/>
+                <a:ea typeface="Calibri"/>
+                <a:cs typeface="Calibri"/>
+                <a:sym typeface="Calibri"/>
+              </a:rPr>
+              <a:t>Relevance agent</a:t>
+            </a:r>
+            <a:endParaRPr b="0" i="0" sz="1400" u="none" cap="none" strike="noStrike">
+              <a:solidFill>
+                <a:srgbClr val="000000"/>
+              </a:solidFill>
+              <a:latin typeface="Arial"/>
+              <a:ea typeface="Arial"/>
+              <a:cs typeface="Arial"/>
+              <a:sym typeface="Arial"/>
+            </a:endParaRPr>
+          </a:p>
+        </p:txBody>
+      </p:sp>
+      <p:sp>
+        <p:nvSpPr>
+          <p:cNvPr id="323" name="Google Shape;323;p25"/>
+          <p:cNvSpPr txBox="1"/>
+          <p:nvPr/>
+        </p:nvSpPr>
+        <p:spPr>
+          <a:xfrm>
+            <a:off x="4572000" y="4818888"/>
+            <a:ext cx="7223760" cy="274320"/>
+          </a:xfrm>
+          <a:prstGeom prst="rect">
+            <a:avLst/>
+          </a:prstGeom>
+          <a:noFill/>
+          <a:ln>
+            <a:noFill/>
+          </a:ln>
+        </p:spPr>
+        <p:txBody>
+          <a:bodyPr anchorCtr="0" anchor="t" bIns="0" lIns="0" spcFirstLastPara="1" rIns="0" wrap="square" tIns="0">
+            <a:spAutoFit/>
+          </a:bodyPr>
+          <a:lstStyle/>
+          <a:p>
+            <a:pPr indent="0" lvl="0" marL="0" marR="0" rtl="0" algn="l">
+              <a:lnSpc>
+                <a:spcPct val="100000"/>
+              </a:lnSpc>
+              <a:spcBef>
+                <a:spcPts val="0"/>
+              </a:spcBef>
+              <a:spcAft>
+                <a:spcPts val="0"/>
+              </a:spcAft>
+              <a:buClr>
+                <a:srgbClr val="000000"/>
+              </a:buClr>
+              <a:buSzPts val="1200"/>
+              <a:buFont typeface="Arial"/>
+              <a:buNone/>
+            </a:pPr>
+            <a:r>
+              <a:rPr b="0" i="0" lang="en-US" sz="1200" u="none" cap="none" strike="noStrike">
+                <a:solidFill>
+                  <a:srgbClr val="0369A1"/>
+                </a:solidFill>
+                <a:latin typeface="Calibri"/>
+                <a:ea typeface="Calibri"/>
+                <a:cs typeface="Calibri"/>
+                <a:sym typeface="Calibri"/>
+              </a:rPr>
+              <a:t>docs.opensearch.org/latest/search-plugins/search-relevance/relevance-agent/</a:t>
+            </a:r>
+            <a:endParaRPr b="0" i="0" sz="1400" u="none" cap="none" strike="noStrike">
+              <a:solidFill>
+                <a:srgbClr val="000000"/>
+              </a:solidFill>
+              <a:latin typeface="Arial"/>
+              <a:ea typeface="Arial"/>
+              <a:cs typeface="Arial"/>
+              <a:sym typeface="Arial"/>
+            </a:endParaRPr>
+          </a:p>
+        </p:txBody>
+      </p:sp>
+      <p:sp>
+        <p:nvSpPr>
+          <p:cNvPr id="324" name="Google Shape;324;p25"/>
+          <p:cNvSpPr txBox="1"/>
+          <p:nvPr/>
+        </p:nvSpPr>
+        <p:spPr>
+          <a:xfrm>
+            <a:off x="457200" y="5294375"/>
+            <a:ext cx="4023360" cy="274320"/>
+          </a:xfrm>
+          <a:prstGeom prst="rect">
+            <a:avLst/>
+          </a:prstGeom>
+          <a:noFill/>
+          <a:ln>
+            <a:noFill/>
+          </a:ln>
+        </p:spPr>
+        <p:txBody>
+          <a:bodyPr anchorCtr="0" anchor="t" bIns="0" lIns="0" spcFirstLastPara="1" rIns="0" wrap="square" tIns="0">
+            <a:spAutoFit/>
+          </a:bodyPr>
+          <a:lstStyle/>
+          <a:p>
+            <a:pPr indent="0" lvl="0" marL="0" marR="0" rtl="0" algn="l">
+              <a:lnSpc>
+                <a:spcPct val="100000"/>
+              </a:lnSpc>
+              <a:spcBef>
+                <a:spcPts val="0"/>
+              </a:spcBef>
+              <a:spcAft>
+                <a:spcPts val="0"/>
+              </a:spcAft>
+              <a:buClr>
+                <a:srgbClr val="000000"/>
+              </a:buClr>
+              <a:buSzPts val="1300"/>
+              <a:buFont typeface="Arial"/>
+              <a:buNone/>
+            </a:pPr>
+            <a:r>
+              <a:rPr b="1" i="0" lang="en-US" sz="1300" u="none" cap="none" strike="noStrike">
+                <a:solidFill>
+                  <a:srgbClr val="0A2540"/>
+                </a:solidFill>
+                <a:latin typeface="Calibri"/>
+                <a:ea typeface="Calibri"/>
+                <a:cs typeface="Calibri"/>
+                <a:sym typeface="Calibri"/>
+              </a:rPr>
+              <a:t>LangGraph evaluator–optimizer workflows</a:t>
+            </a:r>
+            <a:endParaRPr b="0" i="0" sz="1400" u="none" cap="none" strike="noStrike">
+              <a:solidFill>
+                <a:srgbClr val="000000"/>
+              </a:solidFill>
+              <a:latin typeface="Arial"/>
+              <a:ea typeface="Arial"/>
+              <a:cs typeface="Arial"/>
+              <a:sym typeface="Arial"/>
+            </a:endParaRPr>
+          </a:p>
+        </p:txBody>
+      </p:sp>
+      <p:sp>
+        <p:nvSpPr>
+          <p:cNvPr id="325" name="Google Shape;325;p25"/>
+          <p:cNvSpPr txBox="1"/>
+          <p:nvPr/>
+        </p:nvSpPr>
+        <p:spPr>
+          <a:xfrm>
+            <a:off x="4572000" y="5294375"/>
+            <a:ext cx="7223760" cy="274320"/>
+          </a:xfrm>
+          <a:prstGeom prst="rect">
+            <a:avLst/>
+          </a:prstGeom>
+          <a:noFill/>
+          <a:ln>
+            <a:noFill/>
+          </a:ln>
+        </p:spPr>
+        <p:txBody>
+          <a:bodyPr anchorCtr="0" anchor="t" bIns="0" lIns="0" spcFirstLastPara="1" rIns="0" wrap="square" tIns="0">
+            <a:spAutoFit/>
+          </a:bodyPr>
+          <a:lstStyle/>
+          <a:p>
+            <a:pPr indent="0" lvl="0" marL="0" marR="0" rtl="0" algn="l">
+              <a:lnSpc>
+                <a:spcPct val="100000"/>
+              </a:lnSpc>
+              <a:spcBef>
+                <a:spcPts val="0"/>
+              </a:spcBef>
+              <a:spcAft>
+                <a:spcPts val="0"/>
+              </a:spcAft>
+              <a:buClr>
+                <a:srgbClr val="000000"/>
+              </a:buClr>
+              <a:buSzPts val="1200"/>
+              <a:buFont typeface="Arial"/>
+              <a:buNone/>
+            </a:pPr>
+            <a:r>
+              <a:rPr b="0" i="0" lang="en-US" sz="1200" u="none" cap="none" strike="noStrike">
+                <a:solidFill>
+                  <a:srgbClr val="0369A1"/>
+                </a:solidFill>
+                <a:latin typeface="Calibri"/>
+                <a:ea typeface="Calibri"/>
+                <a:cs typeface="Calibri"/>
+                <a:sym typeface="Calibri"/>
+              </a:rPr>
+              <a:t>docs.langchain.com/oss/python/langgraph/workflows-agents</a:t>
+            </a:r>
+            <a:endParaRPr b="0" i="0" sz="1400" u="none" cap="none" strike="noStrike">
+              <a:solidFill>
+                <a:srgbClr val="000000"/>
+              </a:solidFill>
+              <a:latin typeface="Arial"/>
+              <a:ea typeface="Arial"/>
+              <a:cs typeface="Arial"/>
+              <a:sym typeface="Arial"/>
+            </a:endParaRPr>
+          </a:p>
+        </p:txBody>
+      </p:sp>
+      <p:sp>
+        <p:nvSpPr>
+          <p:cNvPr id="326" name="Google Shape;326;p25"/>
+          <p:cNvSpPr txBox="1"/>
+          <p:nvPr/>
+        </p:nvSpPr>
+        <p:spPr>
+          <a:xfrm>
+            <a:off x="457200" y="5769863"/>
+            <a:ext cx="4023360" cy="274320"/>
+          </a:xfrm>
+          <a:prstGeom prst="rect">
+            <a:avLst/>
+          </a:prstGeom>
+          <a:noFill/>
+          <a:ln>
+            <a:noFill/>
+          </a:ln>
+        </p:spPr>
+        <p:txBody>
+          <a:bodyPr anchorCtr="0" anchor="t" bIns="0" lIns="0" spcFirstLastPara="1" rIns="0" wrap="square" tIns="0">
+            <a:spAutoFit/>
+          </a:bodyPr>
+          <a:lstStyle/>
+          <a:p>
+            <a:pPr indent="0" lvl="0" marL="0" marR="0" rtl="0" algn="l">
+              <a:lnSpc>
+                <a:spcPct val="100000"/>
+              </a:lnSpc>
+              <a:spcBef>
+                <a:spcPts val="0"/>
+              </a:spcBef>
+              <a:spcAft>
+                <a:spcPts val="0"/>
+              </a:spcAft>
+              <a:buClr>
+                <a:srgbClr val="000000"/>
+              </a:buClr>
+              <a:buSzPts val="1300"/>
+              <a:buFont typeface="Arial"/>
+              <a:buNone/>
+            </a:pPr>
+            <a:r>
+              <a:rPr b="1" i="0" lang="en-US" sz="1300" u="none" cap="none" strike="noStrike">
+                <a:solidFill>
+                  <a:srgbClr val="0A2540"/>
+                </a:solidFill>
+                <a:latin typeface="Calibri"/>
+                <a:ea typeface="Calibri"/>
+                <a:cs typeface="Calibri"/>
+                <a:sym typeface="Calibri"/>
+              </a:rPr>
+              <a:t>GitHub repository</a:t>
+            </a:r>
+            <a:endParaRPr b="0" i="0" sz="1400" u="none" cap="none" strike="noStrike">
+              <a:solidFill>
+                <a:srgbClr val="000000"/>
+              </a:solidFill>
+              <a:latin typeface="Arial"/>
+              <a:ea typeface="Arial"/>
+              <a:cs typeface="Arial"/>
+              <a:sym typeface="Arial"/>
+            </a:endParaRPr>
+          </a:p>
+        </p:txBody>
+      </p:sp>
+      <p:sp>
+        <p:nvSpPr>
+          <p:cNvPr id="327" name="Google Shape;327;p25"/>
+          <p:cNvSpPr txBox="1"/>
+          <p:nvPr/>
+        </p:nvSpPr>
+        <p:spPr>
+          <a:xfrm>
+            <a:off x="4572000" y="5769863"/>
+            <a:ext cx="7223760" cy="274320"/>
+          </a:xfrm>
+          <a:prstGeom prst="rect">
+            <a:avLst/>
+          </a:prstGeom>
+          <a:noFill/>
+          <a:ln>
+            <a:noFill/>
+          </a:ln>
+        </p:spPr>
+        <p:txBody>
+          <a:bodyPr anchorCtr="0" anchor="t" bIns="0" lIns="0" spcFirstLastPara="1" rIns="0" wrap="square" tIns="0">
+            <a:spAutoFit/>
+          </a:bodyPr>
+          <a:lstStyle/>
+          <a:p>
+            <a:pPr indent="0" lvl="0" marL="0" marR="0" rtl="0" algn="l">
+              <a:lnSpc>
+                <a:spcPct val="100000"/>
+              </a:lnSpc>
+              <a:spcBef>
+                <a:spcPts val="0"/>
+              </a:spcBef>
+              <a:spcAft>
+                <a:spcPts val="0"/>
+              </a:spcAft>
+              <a:buClr>
+                <a:srgbClr val="000000"/>
+              </a:buClr>
+              <a:buSzPts val="1200"/>
+              <a:buFont typeface="Arial"/>
+              <a:buNone/>
+            </a:pPr>
+            <a:r>
+              <a:rPr b="0" i="0" lang="en-US" sz="1200" u="none" cap="none" strike="noStrike">
+                <a:solidFill>
+                  <a:srgbClr val="0369A1"/>
+                </a:solidFill>
+                <a:latin typeface="Calibri"/>
+                <a:ea typeface="Calibri"/>
+                <a:cs typeface="Calibri"/>
+                <a:sym typeface="Calibri"/>
+              </a:rPr>
+              <a:t>github.com/kmwtechnology/opensearch2026-agentic-search</a:t>
+            </a:r>
+            <a:endParaRPr b="0" i="0" sz="1400" u="none" cap="none" strike="noStrike">
+              <a:solidFill>
+                <a:srgbClr val="000000"/>
+              </a:solidFill>
+              <a:latin typeface="Arial"/>
+              <a:ea typeface="Arial"/>
+              <a:cs typeface="Arial"/>
+              <a:sym typeface="Arial"/>
+            </a:endParaRPr>
+          </a:p>
+        </p:txBody>
+      </p:sp>
+      <p:pic>
+        <p:nvPicPr>
+          <p:cNvPr id="328" name="Google Shape;328;p25" title="KMWLogo_blk_blue.png"/>
+          <p:cNvPicPr preferRelativeResize="0"/>
+          <p:nvPr/>
+        </p:nvPicPr>
+        <p:blipFill>
+          <a:blip r:embed="rId3">
+            <a:alphaModFix/>
+          </a:blip>
+          <a:stretch>
+            <a:fillRect/>
+          </a:stretch>
+        </p:blipFill>
+        <p:spPr>
+          <a:xfrm>
+            <a:off x="10059924" y="314175"/>
+            <a:ext cx="1644399" cy="645950"/>
+          </a:xfrm>
+          <a:prstGeom prst="rect">
+            <a:avLst/>
+          </a:prstGeom>
+          <a:noFill/>
+          <a:ln>
+            <a:noFill/>
+          </a:ln>
+        </p:spPr>
+      </p:pic>
     </p:spTree>
   </p:cSld>
   <p:clrMapOvr>
@@ -24106,7 +24090,7 @@
                 <a:cs typeface="Calibri"/>
                 <a:sym typeface="Calibri"/>
               </a:rPr>
-              <a:t>Agentic Search</a:t>
+              <a:t>DEMO</a:t>
             </a:r>
             <a:endParaRPr b="1" sz="4420">
               <a:solidFill>
@@ -28064,6 +28048,285 @@
 </file>
 
 <file path=ppt/theme/theme1.xml><?xml version="1.0" encoding="utf-8"?>
+<a:theme xmlns:a="http://schemas.openxmlformats.org/drawingml/2006/main" xmlns:r="http://schemas.openxmlformats.org/officeDocument/2006/relationships">
+  <a:themeElements>
+    <a:clrScheme name="Default">
+      <a:dk1>
+        <a:srgbClr val="000000"/>
+      </a:dk1>
+      <a:lt1>
+        <a:srgbClr val="FFFFFF"/>
+      </a:lt1>
+      <a:dk2>
+        <a:srgbClr val="158158"/>
+      </a:dk2>
+      <a:lt2>
+        <a:srgbClr val="F3F3F3"/>
+      </a:lt2>
+      <a:accent1>
+        <a:srgbClr val="058DC7"/>
+      </a:accent1>
+      <a:accent2>
+        <a:srgbClr val="50B432"/>
+      </a:accent2>
+      <a:accent3>
+        <a:srgbClr val="ED561B"/>
+      </a:accent3>
+      <a:accent4>
+        <a:srgbClr val="EDEF00"/>
+      </a:accent4>
+      <a:accent5>
+        <a:srgbClr val="24CBE5"/>
+      </a:accent5>
+      <a:accent6>
+        <a:srgbClr val="64E572"/>
+      </a:accent6>
+      <a:hlink>
+        <a:srgbClr val="2200CC"/>
+      </a:hlink>
+      <a:folHlink>
+        <a:srgbClr val="551A8B"/>
+      </a:folHlink>
+    </a:clrScheme>
+    <a:fontScheme name="Office">
+      <a:majorFont>
+        <a:latin typeface="Arial"/>
+        <a:ea typeface=""/>
+        <a:cs typeface=""/>
+        <a:font script="Jpan" typeface="ＭＳ Ｐゴシック"/>
+        <a:font script="Hang" typeface="맑은 고딕"/>
+        <a:font script="Hans" typeface="宋体"/>
+        <a:font script="Hant" typeface="新細明體"/>
+        <a:font script="Arab" typeface="Times New Roman"/>
+        <a:font script="Hebr" typeface="Times New Roman"/>
+        <a:font script="Thai" typeface="Angsana New"/>
+        <a:font script="Ethi" typeface="Nyala"/>
+        <a:font script="Beng" typeface="Vrinda"/>
+        <a:font script="Gujr" typeface="Shruti"/>
+        <a:font script="Khmr" typeface="MoolBoran"/>
+        <a:font script="Knda" typeface="Tunga"/>
+        <a:font script="Guru" typeface="Raavi"/>
+        <a:font script="Cans" typeface="Euphemia"/>
+        <a:font script="Cher" typeface="Plantagenet Cherokee"/>
+        <a:font script="Yiii" typeface="Microsoft Yi Baiti"/>
+        <a:font script="Tibt" typeface="Microsoft Himalaya"/>
+        <a:font script="Thaa" typeface="MV Boli"/>
+        <a:font script="Deva" typeface="Mangal"/>
+        <a:font script="Telu" typeface="Gautami"/>
+        <a:font script="Taml" typeface="Latha"/>
+        <a:font script="Syrc" typeface="Estrangelo Edessa"/>
+        <a:font script="Orya" typeface="Kalinga"/>
+        <a:font script="Mlym" typeface="Kartika"/>
+        <a:font script="Laoo" typeface="DokChampa"/>
+        <a:font script="Sinh" typeface="Iskoola Pota"/>
+        <a:font script="Mong" typeface="Mongolian Baiti"/>
+        <a:font script="Viet" typeface="Times New Roman"/>
+        <a:font script="Uigh" typeface="Microsoft Uighur"/>
+        <a:font script="Geor" typeface="Sylfaen"/>
+      </a:majorFont>
+      <a:minorFont>
+        <a:latin typeface="Arial"/>
+        <a:ea typeface=""/>
+        <a:cs typeface=""/>
+        <a:font script="Jpan" typeface="ＭＳ Ｐゴシック"/>
+        <a:font script="Hang" typeface="맑은 고딕"/>
+        <a:font script="Hans" typeface="宋体"/>
+        <a:font script="Hant" typeface="新細明體"/>
+        <a:font script="Arab" typeface="Arial"/>
+        <a:font script="Hebr" typeface="Arial"/>
+        <a:font script="Thai" typeface="Cordia New"/>
+        <a:font script="Ethi" typeface="Nyala"/>
+        <a:font script="Beng" typeface="Vrinda"/>
+        <a:font script="Gujr" typeface="Shruti"/>
+        <a:font script="Khmr" typeface="DaunPenh"/>
+        <a:font script="Knda" typeface="Tunga"/>
+        <a:font script="Guru" typeface="Raavi"/>
+        <a:font script="Cans" typeface="Euphemia"/>
+        <a:font script="Cher" typeface="Plantagenet Cherokee"/>
+        <a:font script="Yiii" typeface="Microsoft Yi Baiti"/>
+        <a:font script="Tibt" typeface="Microsoft Himalaya"/>
+        <a:font script="Thaa" typeface="MV Boli"/>
+        <a:font script="Deva" typeface="Mangal"/>
+        <a:font script="Telu" typeface="Gautami"/>
+        <a:font script="Taml" typeface="Latha"/>
+        <a:font script="Syrc" typeface="Estrangelo Edessa"/>
+        <a:font script="Orya" typeface="Kalinga"/>
+        <a:font script="Mlym" typeface="Kartika"/>
+        <a:font script="Laoo" typeface="DokChampa"/>
+        <a:font script="Sinh" typeface="Iskoola Pota"/>
+        <a:font script="Mong" typeface="Mongolian Baiti"/>
+        <a:font script="Viet" typeface="Arial"/>
+        <a:font script="Uigh" typeface="Microsoft Uighur"/>
+        <a:font script="Geor" typeface="Sylfaen"/>
+      </a:minorFont>
+    </a:fontScheme>
+    <a:fmtScheme name="Office">
+      <a:fillStyleLst>
+        <a:solidFill>
+          <a:schemeClr val="phClr"/>
+        </a:solidFill>
+        <a:gradFill rotWithShape="1">
+          <a:gsLst>
+            <a:gs pos="0">
+              <a:schemeClr val="phClr">
+                <a:tint val="50000"/>
+                <a:satMod val="300000"/>
+              </a:schemeClr>
+            </a:gs>
+            <a:gs pos="35000">
+              <a:schemeClr val="phClr">
+                <a:tint val="37000"/>
+                <a:satMod val="300000"/>
+              </a:schemeClr>
+            </a:gs>
+            <a:gs pos="100000">
+              <a:schemeClr val="phClr">
+                <a:tint val="15000"/>
+                <a:satMod val="350000"/>
+              </a:schemeClr>
+            </a:gs>
+          </a:gsLst>
+          <a:lin ang="16200000" scaled="1"/>
+        </a:gradFill>
+        <a:gradFill rotWithShape="1">
+          <a:gsLst>
+            <a:gs pos="0">
+              <a:schemeClr val="phClr">
+                <a:tint val="100000"/>
+                <a:shade val="100000"/>
+                <a:satMod val="130000"/>
+              </a:schemeClr>
+            </a:gs>
+            <a:gs pos="100000">
+              <a:schemeClr val="phClr">
+                <a:tint val="50000"/>
+                <a:shade val="100000"/>
+                <a:satMod val="350000"/>
+              </a:schemeClr>
+            </a:gs>
+          </a:gsLst>
+          <a:lin ang="16200000" scaled="0"/>
+        </a:gradFill>
+      </a:fillStyleLst>
+      <a:lnStyleLst>
+        <a:ln w="9525" cap="flat" cmpd="sng" algn="ctr">
+          <a:solidFill>
+            <a:schemeClr val="phClr">
+              <a:shade val="95000"/>
+              <a:satMod val="105000"/>
+            </a:schemeClr>
+          </a:solidFill>
+          <a:prstDash val="solid"/>
+        </a:ln>
+        <a:ln w="25400" cap="flat" cmpd="sng" algn="ctr">
+          <a:solidFill>
+            <a:schemeClr val="phClr"/>
+          </a:solidFill>
+          <a:prstDash val="solid"/>
+        </a:ln>
+        <a:ln w="38100" cap="flat" cmpd="sng" algn="ctr">
+          <a:solidFill>
+            <a:schemeClr val="phClr"/>
+          </a:solidFill>
+          <a:prstDash val="solid"/>
+        </a:ln>
+      </a:lnStyleLst>
+      <a:effectStyleLst>
+        <a:effectStyle>
+          <a:effectLst>
+            <a:outerShdw blurRad="40000" dist="20000" dir="5400000" rotWithShape="0">
+              <a:srgbClr val="000000">
+                <a:alpha val="38000"/>
+              </a:srgbClr>
+            </a:outerShdw>
+          </a:effectLst>
+        </a:effectStyle>
+        <a:effectStyle>
+          <a:effectLst>
+            <a:outerShdw blurRad="40000" dist="23000" dir="5400000" rotWithShape="0">
+              <a:srgbClr val="000000">
+                <a:alpha val="35000"/>
+              </a:srgbClr>
+            </a:outerShdw>
+          </a:effectLst>
+        </a:effectStyle>
+        <a:effectStyle>
+          <a:effectLst>
+            <a:outerShdw blurRad="40000" dist="23000" dir="5400000" rotWithShape="0">
+              <a:srgbClr val="000000">
+                <a:alpha val="35000"/>
+              </a:srgbClr>
+            </a:outerShdw>
+          </a:effectLst>
+          <a:scene3d>
+            <a:camera prst="orthographicFront">
+              <a:rot lat="0" lon="0" rev="0"/>
+            </a:camera>
+            <a:lightRig rig="threePt" dir="t">
+              <a:rot lat="0" lon="0" rev="1200000"/>
+            </a:lightRig>
+          </a:scene3d>
+          <a:sp3d>
+            <a:bevelT w="63500" h="25400"/>
+          </a:sp3d>
+        </a:effectStyle>
+      </a:effectStyleLst>
+      <a:bgFillStyleLst>
+        <a:solidFill>
+          <a:schemeClr val="phClr"/>
+        </a:solidFill>
+        <a:gradFill rotWithShape="1">
+          <a:gsLst>
+            <a:gs pos="0">
+              <a:schemeClr val="phClr">
+                <a:tint val="40000"/>
+                <a:satMod val="350000"/>
+              </a:schemeClr>
+            </a:gs>
+            <a:gs pos="40000">
+              <a:schemeClr val="phClr">
+                <a:tint val="45000"/>
+                <a:shade val="99000"/>
+                <a:satMod val="350000"/>
+              </a:schemeClr>
+            </a:gs>
+            <a:gs pos="100000">
+              <a:schemeClr val="phClr">
+                <a:shade val="20000"/>
+                <a:satMod val="255000"/>
+              </a:schemeClr>
+            </a:gs>
+          </a:gsLst>
+          <a:path path="circle">
+            <a:fillToRect l="50000" t="-80000" r="50000" b="180000"/>
+          </a:path>
+        </a:gradFill>
+        <a:gradFill rotWithShape="1">
+          <a:gsLst>
+            <a:gs pos="0">
+              <a:schemeClr val="phClr">
+                <a:tint val="80000"/>
+                <a:satMod val="300000"/>
+              </a:schemeClr>
+            </a:gs>
+            <a:gs pos="100000">
+              <a:schemeClr val="phClr">
+                <a:shade val="30000"/>
+                <a:satMod val="200000"/>
+              </a:schemeClr>
+            </a:gs>
+          </a:gsLst>
+          <a:path path="circle">
+            <a:fillToRect l="50000" t="50000" r="50000" b="50000"/>
+          </a:path>
+        </a:gradFill>
+      </a:bgFillStyleLst>
+    </a:fmtScheme>
+  </a:themeElements>
+</a:theme>
+</file>
+
+<file path=ppt/theme/theme2.xml><?xml version="1.0" encoding="utf-8"?>
 <a:theme xmlns:a="http://schemas.openxmlformats.org/drawingml/2006/main" xmlns:r="http://schemas.openxmlformats.org/officeDocument/2006/relationships" name="Office Theme">
   <a:themeElements>
     <a:clrScheme name="Office">
@@ -28340,283 +28603,4 @@
     </a:fmtScheme>
   </a:themeElements>
 </a:theme>
-</file>
-
-<file path=ppt/theme/theme2.xml><?xml version="1.0" encoding="utf-8"?>
-<a:theme xmlns:a="http://schemas.openxmlformats.org/drawingml/2006/main" xmlns:r="http://schemas.openxmlformats.org/officeDocument/2006/relationships">
-  <a:themeElements>
-    <a:clrScheme name="Default">
-      <a:dk1>
-        <a:srgbClr val="000000"/>
-      </a:dk1>
-      <a:lt1>
-        <a:srgbClr val="FFFFFF"/>
-      </a:lt1>
-      <a:dk2>
-        <a:srgbClr val="158158"/>
-      </a:dk2>
-      <a:lt2>
-        <a:srgbClr val="F3F3F3"/>
-      </a:lt2>
-      <a:accent1>
-        <a:srgbClr val="058DC7"/>
-      </a:accent1>
-      <a:accent2>
-        <a:srgbClr val="50B432"/>
-      </a:accent2>
-      <a:accent3>
-        <a:srgbClr val="ED561B"/>
-      </a:accent3>
-      <a:accent4>
-        <a:srgbClr val="EDEF00"/>
-      </a:accent4>
-      <a:accent5>
-        <a:srgbClr val="24CBE5"/>
-      </a:accent5>
-      <a:accent6>
-        <a:srgbClr val="64E572"/>
-      </a:accent6>
-      <a:hlink>
-        <a:srgbClr val="2200CC"/>
-      </a:hlink>
-      <a:folHlink>
-        <a:srgbClr val="551A8B"/>
-      </a:folHlink>
-    </a:clrScheme>
-    <a:fontScheme name="Office">
-      <a:majorFont>
-        <a:latin typeface="Arial"/>
-        <a:ea typeface=""/>
-        <a:cs typeface=""/>
-        <a:font script="Jpan" typeface="ＭＳ Ｐゴシック"/>
-        <a:font script="Hang" typeface="맑은 고딕"/>
-        <a:font script="Hans" typeface="宋体"/>
-        <a:font script="Hant" typeface="新細明體"/>
-        <a:font script="Arab" typeface="Times New Roman"/>
-        <a:font script="Hebr" typeface="Times New Roman"/>
-        <a:font script="Thai" typeface="Angsana New"/>
-        <a:font script="Ethi" typeface="Nyala"/>
-        <a:font script="Beng" typeface="Vrinda"/>
-        <a:font script="Gujr" typeface="Shruti"/>
-        <a:font script="Khmr" typeface="MoolBoran"/>
-        <a:font script="Knda" typeface="Tunga"/>
-        <a:font script="Guru" typeface="Raavi"/>
-        <a:font script="Cans" typeface="Euphemia"/>
-        <a:font script="Cher" typeface="Plantagenet Cherokee"/>
-        <a:font script="Yiii" typeface="Microsoft Yi Baiti"/>
-        <a:font script="Tibt" typeface="Microsoft Himalaya"/>
-        <a:font script="Thaa" typeface="MV Boli"/>
-        <a:font script="Deva" typeface="Mangal"/>
-        <a:font script="Telu" typeface="Gautami"/>
-        <a:font script="Taml" typeface="Latha"/>
-        <a:font script="Syrc" typeface="Estrangelo Edessa"/>
-        <a:font script="Orya" typeface="Kalinga"/>
-        <a:font script="Mlym" typeface="Kartika"/>
-        <a:font script="Laoo" typeface="DokChampa"/>
-        <a:font script="Sinh" typeface="Iskoola Pota"/>
-        <a:font script="Mong" typeface="Mongolian Baiti"/>
-        <a:font script="Viet" typeface="Times New Roman"/>
-        <a:font script="Uigh" typeface="Microsoft Uighur"/>
-        <a:font script="Geor" typeface="Sylfaen"/>
-      </a:majorFont>
-      <a:minorFont>
-        <a:latin typeface="Arial"/>
-        <a:ea typeface=""/>
-        <a:cs typeface=""/>
-        <a:font script="Jpan" typeface="ＭＳ Ｐゴシック"/>
-        <a:font script="Hang" typeface="맑은 고딕"/>
-        <a:font script="Hans" typeface="宋体"/>
-        <a:font script="Hant" typeface="新細明體"/>
-        <a:font script="Arab" typeface="Arial"/>
-        <a:font script="Hebr" typeface="Arial"/>
-        <a:font script="Thai" typeface="Cordia New"/>
-        <a:font script="Ethi" typeface="Nyala"/>
-        <a:font script="Beng" typeface="Vrinda"/>
-        <a:font script="Gujr" typeface="Shruti"/>
-        <a:font script="Khmr" typeface="DaunPenh"/>
-        <a:font script="Knda" typeface="Tunga"/>
-        <a:font script="Guru" typeface="Raavi"/>
-        <a:font script="Cans" typeface="Euphemia"/>
-        <a:font script="Cher" typeface="Plantagenet Cherokee"/>
-        <a:font script="Yiii" typeface="Microsoft Yi Baiti"/>
-        <a:font script="Tibt" typeface="Microsoft Himalaya"/>
-        <a:font script="Thaa" typeface="MV Boli"/>
-        <a:font script="Deva" typeface="Mangal"/>
-        <a:font script="Telu" typeface="Gautami"/>
-        <a:font script="Taml" typeface="Latha"/>
-        <a:font script="Syrc" typeface="Estrangelo Edessa"/>
-        <a:font script="Orya" typeface="Kalinga"/>
-        <a:font script="Mlym" typeface="Kartika"/>
-        <a:font script="Laoo" typeface="DokChampa"/>
-        <a:font script="Sinh" typeface="Iskoola Pota"/>
-        <a:font script="Mong" typeface="Mongolian Baiti"/>
-        <a:font script="Viet" typeface="Arial"/>
-        <a:font script="Uigh" typeface="Microsoft Uighur"/>
-        <a:font script="Geor" typeface="Sylfaen"/>
-      </a:minorFont>
-    </a:fontScheme>
-    <a:fmtScheme name="Office">
-      <a:fillStyleLst>
-        <a:solidFill>
-          <a:schemeClr val="phClr"/>
-        </a:solidFill>
-        <a:gradFill rotWithShape="1">
-          <a:gsLst>
-            <a:gs pos="0">
-              <a:schemeClr val="phClr">
-                <a:tint val="50000"/>
-                <a:satMod val="300000"/>
-              </a:schemeClr>
-            </a:gs>
-            <a:gs pos="35000">
-              <a:schemeClr val="phClr">
-                <a:tint val="37000"/>
-                <a:satMod val="300000"/>
-              </a:schemeClr>
-            </a:gs>
-            <a:gs pos="100000">
-              <a:schemeClr val="phClr">
-                <a:tint val="15000"/>
-                <a:satMod val="350000"/>
-              </a:schemeClr>
-            </a:gs>
-          </a:gsLst>
-          <a:lin ang="16200000" scaled="1"/>
-        </a:gradFill>
-        <a:gradFill rotWithShape="1">
-          <a:gsLst>
-            <a:gs pos="0">
-              <a:schemeClr val="phClr">
-                <a:tint val="100000"/>
-                <a:shade val="100000"/>
-                <a:satMod val="130000"/>
-              </a:schemeClr>
-            </a:gs>
-            <a:gs pos="100000">
-              <a:schemeClr val="phClr">
-                <a:tint val="50000"/>
-                <a:shade val="100000"/>
-                <a:satMod val="350000"/>
-              </a:schemeClr>
-            </a:gs>
-          </a:gsLst>
-          <a:lin ang="16200000" scaled="0"/>
-        </a:gradFill>
-      </a:fillStyleLst>
-      <a:lnStyleLst>
-        <a:ln w="9525" cap="flat" cmpd="sng" algn="ctr">
-          <a:solidFill>
-            <a:schemeClr val="phClr">
-              <a:shade val="95000"/>
-              <a:satMod val="105000"/>
-            </a:schemeClr>
-          </a:solidFill>
-          <a:prstDash val="solid"/>
-        </a:ln>
-        <a:ln w="25400" cap="flat" cmpd="sng" algn="ctr">
-          <a:solidFill>
-            <a:schemeClr val="phClr"/>
-          </a:solidFill>
-          <a:prstDash val="solid"/>
-        </a:ln>
-        <a:ln w="38100" cap="flat" cmpd="sng" algn="ctr">
-          <a:solidFill>
-            <a:schemeClr val="phClr"/>
-          </a:solidFill>
-          <a:prstDash val="solid"/>
-        </a:ln>
-      </a:lnStyleLst>
-      <a:effectStyleLst>
-        <a:effectStyle>
-          <a:effectLst>
-            <a:outerShdw blurRad="40000" dist="20000" dir="5400000" rotWithShape="0">
-              <a:srgbClr val="000000">
-                <a:alpha val="38000"/>
-              </a:srgbClr>
-            </a:outerShdw>
-          </a:effectLst>
-        </a:effectStyle>
-        <a:effectStyle>
-          <a:effectLst>
-            <a:outerShdw blurRad="40000" dist="23000" dir="5400000" rotWithShape="0">
-              <a:srgbClr val="000000">
-                <a:alpha val="35000"/>
-              </a:srgbClr>
-            </a:outerShdw>
-          </a:effectLst>
-        </a:effectStyle>
-        <a:effectStyle>
-          <a:effectLst>
-            <a:outerShdw blurRad="40000" dist="23000" dir="5400000" rotWithShape="0">
-              <a:srgbClr val="000000">
-                <a:alpha val="35000"/>
-              </a:srgbClr>
-            </a:outerShdw>
-          </a:effectLst>
-          <a:scene3d>
-            <a:camera prst="orthographicFront">
-              <a:rot lat="0" lon="0" rev="0"/>
-            </a:camera>
-            <a:lightRig rig="threePt" dir="t">
-              <a:rot lat="0" lon="0" rev="1200000"/>
-            </a:lightRig>
-          </a:scene3d>
-          <a:sp3d>
-            <a:bevelT w="63500" h="25400"/>
-          </a:sp3d>
-        </a:effectStyle>
-      </a:effectStyleLst>
-      <a:bgFillStyleLst>
-        <a:solidFill>
-          <a:schemeClr val="phClr"/>
-        </a:solidFill>
-        <a:gradFill rotWithShape="1">
-          <a:gsLst>
-            <a:gs pos="0">
-              <a:schemeClr val="phClr">
-                <a:tint val="40000"/>
-                <a:satMod val="350000"/>
-              </a:schemeClr>
-            </a:gs>
-            <a:gs pos="40000">
-              <a:schemeClr val="phClr">
-                <a:tint val="45000"/>
-                <a:shade val="99000"/>
-                <a:satMod val="350000"/>
-              </a:schemeClr>
-            </a:gs>
-            <a:gs pos="100000">
-              <a:schemeClr val="phClr">
-                <a:shade val="20000"/>
-                <a:satMod val="255000"/>
-              </a:schemeClr>
-            </a:gs>
-          </a:gsLst>
-          <a:path path="circle">
-            <a:fillToRect l="50000" t="-80000" r="50000" b="180000"/>
-          </a:path>
-        </a:gradFill>
-        <a:gradFill rotWithShape="1">
-          <a:gsLst>
-            <a:gs pos="0">
-              <a:schemeClr val="phClr">
-                <a:tint val="80000"/>
-                <a:satMod val="300000"/>
-              </a:schemeClr>
-            </a:gs>
-            <a:gs pos="100000">
-              <a:schemeClr val="phClr">
-                <a:shade val="30000"/>
-                <a:satMod val="200000"/>
-              </a:schemeClr>
-            </a:gs>
-          </a:gsLst>
-          <a:path path="circle">
-            <a:fillToRect l="50000" t="50000" r="50000" b="50000"/>
-          </a:path>
-        </a:gradFill>
-      </a:bgFillStyleLst>
-    </a:fmtScheme>
-  </a:themeElements>
-</a:theme>
 </file>
</xml_diff>

<commit_message>
docs: update Agentic Search Talk draft presentation
</commit_message>
<xml_diff>
--- a/docs/presentation/Agentic_Search_Talk_Draft_v1.pptx
+++ b/docs/presentation/Agentic_Search_Talk_Draft_v1.pptx
@@ -882,10 +882,10 @@
           <a:p>
             <a:pPr indent="0" lvl="0" marL="0" rtl="0" algn="l">
               <a:lnSpc>
-                <a:spcPct val="100000"/>
-              </a:lnSpc>
-              <a:spcBef>
-                <a:spcPts val="0"/>
+                <a:spcPct val="115000"/>
+              </a:lnSpc>
+              <a:spcBef>
+                <a:spcPts val="1200"/>
               </a:spcBef>
               <a:spcAft>
                 <a:spcPts val="0"/>
@@ -894,7 +894,28 @@
               <a:buNone/>
             </a:pPr>
             <a:r>
-              <a:t/>
+              <a:rPr lang="en-US"/>
+              <a:t>Title</a:t>
+            </a:r>
+            <a:endParaRPr/>
+          </a:p>
+          <a:p>
+            <a:pPr indent="0" lvl="0" marL="0" rtl="0" algn="l">
+              <a:lnSpc>
+                <a:spcPct val="115000"/>
+              </a:lnSpc>
+              <a:spcBef>
+                <a:spcPts val="1200"/>
+              </a:spcBef>
+              <a:spcAft>
+                <a:spcPts val="1200"/>
+              </a:spcAft>
+              <a:buSzPts val="1100"/>
+              <a:buNone/>
+            </a:pPr>
+            <a:r>
+              <a:rPr lang="en-US"/>
+              <a:t>I'm Kevin Butler, a search engineer at KMW Technology — we do search relevancy consulting. This isn't a product pitch: it's a live demonstration of how we solve real search-relevance problems using modern agentic tooling built on top of OpenSearch. Everything you'll see today is running live, against a real e-commerce catalog, not canned screenshots. By the end, you'll have watched one LangGraph agent classify intent, retry its own retrieval, get graded against real relevance judgments, and fix a wrong catalog tag live — all in the same running application.</a:t>
             </a:r>
             <a:endParaRPr/>
           </a:p>
@@ -1052,7 +1073,39 @@
               <a:buNone/>
             </a:pPr>
             <a:r>
+              <a:rPr lang="en-US"/>
+              <a:t>Demo 2 Recap</a:t>
+            </a:r>
+            <a:endParaRPr/>
+          </a:p>
+          <a:p>
+            <a:pPr indent="0" lvl="0" marL="0" rtl="0" algn="l">
+              <a:spcBef>
+                <a:spcPts val="0"/>
+              </a:spcBef>
+              <a:spcAft>
+                <a:spcPts val="0"/>
+              </a:spcAft>
+              <a:buNone/>
+            </a:pPr>
+            <a:r>
               <a:t/>
+            </a:r>
+            <a:endParaRPr/>
+          </a:p>
+          <a:p>
+            <a:pPr indent="0" lvl="0" marL="0" rtl="0" algn="l">
+              <a:spcBef>
+                <a:spcPts val="0"/>
+              </a:spcBef>
+              <a:spcAft>
+                <a:spcPts val="0"/>
+              </a:spcAft>
+              <a:buNone/>
+            </a:pPr>
+            <a:r>
+              <a:rPr lang="en-US"/>
+              <a:t>This is the one grounded entirely in real data, not vibes. "Sewing machine" is a query that has ground truth in the ESCI dataset, so instead of trusting our own internal confidence scores, we can score every stage of our pipeline against Amazon's own human relevance judgments using NDCG at 10. Stock BM25 starts at 0.81. Just optimizing BM25 gets us to 0.91. Hybrid search — combining lexical and vector retrieval — hits 0.95, the high point. Reranking alone, without the hybrid step, gets 0.92. The headline: hybrid beats stock by 0.14 NDCG points, and every optimization stage beat the baseline — graded by an external, academic ground truth, not a number we invented.</a:t>
             </a:r>
             <a:endParaRPr/>
           </a:p>
@@ -1165,7 +1218,39 @@
               <a:buNone/>
             </a:pPr>
             <a:r>
+              <a:rPr lang="en-US"/>
+              <a:t>Demo 3 Recap</a:t>
+            </a:r>
+            <a:endParaRPr/>
+          </a:p>
+          <a:p>
+            <a:pPr indent="0" lvl="0" marL="0" rtl="0" algn="l">
+              <a:spcBef>
+                <a:spcPts val="0"/>
+              </a:spcBef>
+              <a:spcAft>
+                <a:spcPts val="0"/>
+              </a:spcAft>
+              <a:buNone/>
+            </a:pPr>
+            <a:r>
               <a:t/>
+            </a:r>
+            <a:endParaRPr/>
+          </a:p>
+          <a:p>
+            <a:pPr indent="0" lvl="0" marL="0" rtl="0" algn="l">
+              <a:spcBef>
+                <a:spcPts val="0"/>
+              </a:spcBef>
+              <a:spcAft>
+                <a:spcPts val="0"/>
+              </a:spcAft>
+              <a:buNone/>
+            </a:pPr>
+            <a:r>
+              <a:rPr lang="en-US"/>
+              <a:t>This is the centerpiece, so I'm going to slow down here. Phase one: a user searches "show me tan boots." The filter resolves to "yellow" — the record literally reads product_color_primary: yellow — and it passes the quality gate anyway, because a wrong-but-mapped tag looks perfectly confident to every automated check. The user pushes back: "that's not tan, that's tagged yellow, which is wrong." Phase two: that correction signal gets verified, and it triggers a real Lucille indexing pipeline re-index — not a mock, not a canned animation — across all 9,618 products, reclassifying the color_primary field, with no manual query tuning involved. Phase three: same query, new session, and the filter now correctly reads "brown" — permanently, in the catalog itself, not just for this one session. The takeaway: this was a confidently wrong result that passed every automated check we had, and what fixed it wasn't a smarter query — it was the catalog changing underneath the query.</a:t>
             </a:r>
             <a:endParaRPr/>
           </a:p>
@@ -1278,7 +1363,39 @@
               <a:buNone/>
             </a:pPr>
             <a:r>
+              <a:rPr lang="en-US"/>
+              <a:t>Demo 3 Extension (optional)</a:t>
+            </a:r>
+            <a:endParaRPr/>
+          </a:p>
+          <a:p>
+            <a:pPr indent="0" lvl="0" marL="0" rtl="0" algn="l">
+              <a:spcBef>
+                <a:spcPts val="0"/>
+              </a:spcBef>
+              <a:spcAft>
+                <a:spcPts val="0"/>
+              </a:spcAft>
+              <a:buNone/>
+            </a:pPr>
+            <a:r>
               <a:t/>
+            </a:r>
+            <a:endParaRPr/>
+          </a:p>
+          <a:p>
+            <a:pPr indent="0" lvl="0" marL="0" rtl="0" algn="l">
+              <a:spcBef>
+                <a:spcPts val="0"/>
+              </a:spcBef>
+              <a:spcAft>
+                <a:spcPts val="0"/>
+              </a:spcAft>
+              <a:buNone/>
+            </a:pPr>
+            <a:r>
+              <a:rPr lang="en-US"/>
+              <a:t>Time permitting, here's the other side of the same mechanism — not correcting a wrong value, but growing a missing one. "Waterproof hiking boots" expects a direct waterproof filter, but that attribute doesn't exist in the schema yet — is_waterproof is undefined, so the system falls back to unstructured text matching. The Lucille indexing pipeline extracts that attribute straight out of specs and product descriptions and bulk-augments all 9,618 products with the new derived field. Run the same query again in a new session, and it now matches is_waterproof: true directly, as a real structured filter. So the same loop that fixes a wrong tag can also grow the taxonomy to support filter dimensions that didn't exist before — agentic search isn't just correcting errors, it's continuously evolving the schema.</a:t>
             </a:r>
             <a:endParaRPr/>
           </a:p>
@@ -1391,7 +1508,39 @@
               <a:buNone/>
             </a:pPr>
             <a:r>
+              <a:rPr lang="en-US"/>
+              <a:t>Closing / Takeaways</a:t>
+            </a:r>
+            <a:endParaRPr/>
+          </a:p>
+          <a:p>
+            <a:pPr indent="0" lvl="0" marL="0" rtl="0" algn="l">
+              <a:spcBef>
+                <a:spcPts val="0"/>
+              </a:spcBef>
+              <a:spcAft>
+                <a:spcPts val="0"/>
+              </a:spcAft>
+              <a:buNone/>
+            </a:pPr>
+            <a:r>
               <a:t/>
+            </a:r>
+            <a:endParaRPr/>
+          </a:p>
+          <a:p>
+            <a:pPr indent="0" lvl="0" marL="0" rtl="0" algn="l">
+              <a:spcBef>
+                <a:spcPts val="0"/>
+              </a:spcBef>
+              <a:spcAft>
+                <a:spcPts val="0"/>
+              </a:spcAft>
+              <a:buNone/>
+            </a:pPr>
+            <a:r>
+              <a:rPr lang="en-US"/>
+              <a:t>Pulling it together: hybrid retrieval, reranking, and one bounded retry — never an unconstrained loop that could spin forever. Judgments diagnose relevance when ground truth exists; a confidence proxy carries every other query. The centerpiece is an agent that enriches the catalog, not just the answer in front of you. And every one of those decisions — intent, alpha, retry, repair — is visible in the observability panel; nothing is a black box. If there's one sentence to take away: agentic search doesn't replace relevancy tuning — it's the layer that knows when your retrieval, your reranker, or your catalog itself is the thing that needs enrichment.</a:t>
             </a:r>
             <a:endParaRPr/>
           </a:p>
@@ -1504,7 +1653,39 @@
               <a:buNone/>
             </a:pPr>
             <a:r>
+              <a:rPr lang="en-US"/>
+              <a:t>What's Next / Q&amp;A Runway</a:t>
+            </a:r>
+            <a:endParaRPr/>
+          </a:p>
+          <a:p>
+            <a:pPr indent="0" lvl="0" marL="0" rtl="0" algn="l">
+              <a:spcBef>
+                <a:spcPts val="0"/>
+              </a:spcBef>
+              <a:spcAft>
+                <a:spcPts val="0"/>
+              </a:spcAft>
+              <a:buNone/>
+            </a:pPr>
+            <a:r>
               <a:t/>
+            </a:r>
+            <a:endParaRPr/>
+          </a:p>
+          <a:p>
+            <a:pPr indent="0" lvl="0" marL="0" rtl="0" algn="l">
+              <a:spcBef>
+                <a:spcPts val="0"/>
+              </a:spcBef>
+              <a:spcAft>
+                <a:spcPts val="0"/>
+              </a:spcAft>
+              <a:buNone/>
+            </a:pPr>
+            <a:r>
+              <a:rPr lang="en-US"/>
+              <a:t>A few honest directions this could go next, and good territory for questions. First, extending the correction loop beyond simple fields — nested schemas, compatibility matrices, multi-value attributes. Second, letting alpha tuning itself become evaluator-driven and adaptive in real time, rather than following the fixed heuristics you saw today. Third, scaling attribute growth past color and material into other filtering dimensions entirely. The common thread across all three: moving from reactive query fixes toward continuous, proactive catalog evolution.</a:t>
             </a:r>
             <a:endParaRPr/>
           </a:p>
@@ -1561,6 +1742,46 @@
             <a:noAutofit/>
           </a:bodyPr>
           <a:lstStyle/>
+          <a:p>
+            <a:pPr indent="0" lvl="0" marL="0" rtl="0" algn="l">
+              <a:lnSpc>
+                <a:spcPct val="100000"/>
+              </a:lnSpc>
+              <a:spcBef>
+                <a:spcPts val="0"/>
+              </a:spcBef>
+              <a:spcAft>
+                <a:spcPts val="0"/>
+              </a:spcAft>
+              <a:buSzPts val="1100"/>
+              <a:buNone/>
+            </a:pPr>
+            <a:r>
+              <a:rPr lang="en-US"/>
+              <a:t>Thank You</a:t>
+            </a:r>
+            <a:endParaRPr/>
+          </a:p>
+          <a:p>
+            <a:pPr indent="0" lvl="0" marL="0" rtl="0" algn="l">
+              <a:lnSpc>
+                <a:spcPct val="100000"/>
+              </a:lnSpc>
+              <a:spcBef>
+                <a:spcPts val="0"/>
+              </a:spcBef>
+              <a:spcAft>
+                <a:spcPts val="0"/>
+              </a:spcAft>
+              <a:buSzPts val="1100"/>
+              <a:buNone/>
+            </a:pPr>
+            <a:r>
+              <a:rPr lang="en-US"/>
+              <a:t>That's the talk — one live agent, three demos, and a catalog that fixes itself in front of you. Happy to take questions, and the GitHub repo and further reading are on the next slide if you want to dig in afterward.</a:t>
+            </a:r>
+            <a:endParaRPr/>
+          </a:p>
           <a:p>
             <a:pPr indent="0" lvl="0" marL="0" rtl="0" algn="l">
               <a:lnSpc>
@@ -1693,6 +1914,65 @@
               <a:buNone/>
             </a:pPr>
             <a:r>
+              <a:rPr lang="en-US"/>
+              <a:t>Sources</a:t>
+            </a:r>
+            <a:endParaRPr/>
+          </a:p>
+          <a:p>
+            <a:pPr indent="0" lvl="0" marL="0" rtl="0" algn="l">
+              <a:lnSpc>
+                <a:spcPct val="100000"/>
+              </a:lnSpc>
+              <a:spcBef>
+                <a:spcPts val="0"/>
+              </a:spcBef>
+              <a:spcAft>
+                <a:spcPts val="0"/>
+              </a:spcAft>
+              <a:buSzPts val="1100"/>
+              <a:buNone/>
+            </a:pPr>
+            <a:r>
+              <a:t/>
+            </a:r>
+            <a:endParaRPr/>
+          </a:p>
+          <a:p>
+            <a:pPr indent="0" lvl="0" marL="0" rtl="0" algn="l">
+              <a:lnSpc>
+                <a:spcPct val="100000"/>
+              </a:lnSpc>
+              <a:spcBef>
+                <a:spcPts val="0"/>
+              </a:spcBef>
+              <a:spcAft>
+                <a:spcPts val="0"/>
+              </a:spcAft>
+              <a:buSzPts val="1100"/>
+              <a:buNone/>
+            </a:pPr>
+            <a:r>
+              <a:rPr lang="en-US"/>
+              <a:t>These are the OpenSearch docs on the Search Relevance Workbench and judgments-based evaluation that this whole benchmarking approach is built on, plus the LangGraph evaluator-optimizer pattern the agent loop follows, and the GitHub repo for everything you saw today, code included.</a:t>
+            </a:r>
+            <a:endParaRPr/>
+          </a:p>
+          <a:p>
+            <a:pPr indent="0" lvl="0" marL="0" rtl="0" algn="l">
+              <a:lnSpc>
+                <a:spcPct val="100000"/>
+              </a:lnSpc>
+              <a:spcBef>
+                <a:spcPts val="0"/>
+              </a:spcBef>
+              <a:spcAft>
+                <a:spcPts val="0"/>
+              </a:spcAft>
+              <a:buSzPts val="1100"/>
+              <a:buNone/>
+            </a:pPr>
+            <a:r>
               <a:t/>
             </a:r>
             <a:endParaRPr/>
@@ -1793,8 +2073,11 @@
           <a:lstStyle/>
           <a:p>
             <a:pPr indent="0" lvl="0" marL="0" rtl="0" algn="l">
-              <a:spcBef>
-                <a:spcPts val="0"/>
+              <a:lnSpc>
+                <a:spcPct val="115000"/>
+              </a:lnSpc>
+              <a:spcBef>
+                <a:spcPts val="1200"/>
               </a:spcBef>
               <a:spcAft>
                 <a:spcPts val="0"/>
@@ -1803,7 +2086,54 @@
             </a:pPr>
             <a:r>
               <a:rPr lang="en-US"/>
-              <a:t>When we talk about ESCI, we are referring to Amazon's Shopping Queries Dataset, which contains roughly 1.8 million real shopper queries paired with human relevance judgments. The four categories are Explicit, meaning an exact query match; Substitute, meaning a functional alternative; Complement, meaning an item that pairs well or is an accessory; and Irrelevant, meaning an unrelated search result. We rely on this dataset because it captures authentic shopper intent rather than synthetic queries, providing a rigorous benchmark for our retrieval pipeline.</a:t>
+              <a:t>The Problem / ESCI dataset</a:t>
+            </a:r>
+            <a:endParaRPr/>
+          </a:p>
+          <a:p>
+            <a:pPr indent="0" lvl="0" marL="0" rtl="0" algn="l">
+              <a:spcBef>
+                <a:spcPts val="1200"/>
+              </a:spcBef>
+              <a:spcAft>
+                <a:spcPts val="0"/>
+              </a:spcAft>
+              <a:buNone/>
+            </a:pPr>
+            <a:r>
+              <a:rPr lang="en-US"/>
+              <a:t>The core problem with modern RAG-style search: weak retrieval is invisible. When the generator is fluent, it writes right over bad retrieval — the answer reads confidently even when the underlying documents are wrong. Confidence is not evidence. That's the question this whole talk answers: how can a search system recognize when its own retrieval is weak, change course, and — when the root cause is bad catalog data — fix that data on the fly, instead of just serving a better-sounding wrong answer?</a:t>
+            </a:r>
+            <a:endParaRPr/>
+          </a:p>
+          <a:p>
+            <a:pPr indent="0" lvl="0" marL="0" rtl="0" algn="l">
+              <a:spcBef>
+                <a:spcPts val="0"/>
+              </a:spcBef>
+              <a:spcAft>
+                <a:spcPts val="0"/>
+              </a:spcAft>
+              <a:buNone/>
+            </a:pPr>
+            <a:r>
+              <a:t/>
+            </a:r>
+            <a:endParaRPr/>
+          </a:p>
+          <a:p>
+            <a:pPr indent="0" lvl="0" marL="0" rtl="0" algn="l">
+              <a:spcBef>
+                <a:spcPts val="0"/>
+              </a:spcBef>
+              <a:spcAft>
+                <a:spcPts val="0"/>
+              </a:spcAft>
+              <a:buNone/>
+            </a:pPr>
+            <a:r>
+              <a:rPr lang="en-US"/>
+              <a:t>We benchmark all of this against Amazon's ESCI dataset — Amazon's Shopping Queries Dataset — roughly 1.8 million real shopper queries paired with human relevance judgments. The four categories are Explicit (an exact query match), Substitute (a functional alternative), Complement (an item that pairs well or is an accessory), and Irrelevant (an unrelated result). We use ESCI because it's real shopper intent, not synthetic queries, and it ships with graded judgments we can score against — that's what Demo 2 uses directly.</a:t>
             </a:r>
             <a:endParaRPr/>
           </a:p>
@@ -1942,8 +2272,11 @@
           <a:lstStyle/>
           <a:p>
             <a:pPr indent="0" lvl="0" marL="0" rtl="0" algn="l">
-              <a:spcBef>
-                <a:spcPts val="0"/>
+              <a:lnSpc>
+                <a:spcPct val="115000"/>
+              </a:lnSpc>
+              <a:spcBef>
+                <a:spcPts val="1200"/>
               </a:spcBef>
               <a:spcAft>
                 <a:spcPts val="0"/>
@@ -1951,7 +2284,24 @@
               <a:buNone/>
             </a:pPr>
             <a:r>
-              <a:t/>
+              <a:rPr lang="en-US"/>
+              <a:t>Cast of Characters</a:t>
+            </a:r>
+            <a:endParaRPr/>
+          </a:p>
+          <a:p>
+            <a:pPr indent="0" lvl="0" marL="0" rtl="0" algn="l">
+              <a:spcBef>
+                <a:spcPts val="1200"/>
+              </a:spcBef>
+              <a:spcAft>
+                <a:spcPts val="0"/>
+              </a:spcAft>
+              <a:buNone/>
+            </a:pPr>
+            <a:r>
+              <a:rPr lang="en-US"/>
+              <a:t>Before we get into the pipeline, four names you'll hear repeatedly. The Lucille indexing pipeline is the Java ETL that processes and transforms documents before they ever reach the search index — it's not OpenSearch itself, it's what feeds it. OpenSearch is where documents actually live, giving us both BM25 lexical keyword matching and vector-based semantic retrieval in the same index. The LangGraph agent is the orchestration layer — it runs the continuous reasoning loop: classify intent, retrieve, rerank, verify. And Gemini is the foundation model the agent calls into for intent classification, generation, and quality judgment — it's hosted on Google Cloud in this build, though the same LangGraph orchestration would run unchanged against a model running locally. Four modular roles, working in tandem, is what makes the self-correcting behavior in the rest of the talk possible.</a:t>
             </a:r>
             <a:endParaRPr/>
           </a:p>
@@ -2064,7 +2414,39 @@
               <a:buNone/>
             </a:pPr>
             <a:r>
+              <a:rPr lang="en-US"/>
+              <a:t>Full Toolset</a:t>
+            </a:r>
+            <a:endParaRPr/>
+          </a:p>
+          <a:p>
+            <a:pPr indent="0" lvl="0" marL="0" rtl="0" algn="l">
+              <a:spcBef>
+                <a:spcPts val="0"/>
+              </a:spcBef>
+              <a:spcAft>
+                <a:spcPts val="0"/>
+              </a:spcAft>
+              <a:buNone/>
+            </a:pPr>
+            <a:r>
               <a:t/>
+            </a:r>
+            <a:endParaRPr/>
+          </a:p>
+          <a:p>
+            <a:pPr indent="0" lvl="0" marL="0" rtl="0" algn="l">
+              <a:spcBef>
+                <a:spcPts val="0"/>
+              </a:spcBef>
+              <a:spcAft>
+                <a:spcPts val="0"/>
+              </a:spcAft>
+              <a:buNone/>
+            </a:pPr>
+            <a:r>
+              <a:rPr lang="en-US"/>
+              <a:t>This is the reference slide for the full stack, top to bottom — I'll move through it quickly now, and it's here if anyone wants to come back to it during Q&amp;A. The bottom half is the baseline relevancy work most search teams already have: type-ahead and autocomplete, spellcheck and phonetic matching, synonym expansion, field boosts. None of that goes away — the agent doesn't replace it, it sits on top of it. The top half is the agentic layer this talk is actually about: intent classification and alpha weighting, cross-encoder reranking with a bounded quality-gate retry, taxonomy growth and schema correction, and an LLM judge doing continuous ESCI-based evaluation. The thesis in one line: a high-quality baseline retrieval stack, plus an agentic feedback loop that keeps correcting both the query and the catalog underneath it.</a:t>
             </a:r>
             <a:endParaRPr/>
           </a:p>
@@ -2177,7 +2559,39 @@
               <a:buNone/>
             </a:pPr>
             <a:r>
+              <a:rPr lang="en-US"/>
+              <a:t>Talk Thesis / The Agentic Loop</a:t>
+            </a:r>
+            <a:endParaRPr/>
+          </a:p>
+          <a:p>
+            <a:pPr indent="0" lvl="0" marL="0" rtl="0" algn="l">
+              <a:spcBef>
+                <a:spcPts val="0"/>
+              </a:spcBef>
+              <a:spcAft>
+                <a:spcPts val="0"/>
+              </a:spcAft>
+              <a:buNone/>
+            </a:pPr>
+            <a:r>
               <a:t/>
+            </a:r>
+            <a:endParaRPr/>
+          </a:p>
+          <a:p>
+            <a:pPr indent="0" lvl="0" marL="0" rtl="0" algn="l">
+              <a:spcBef>
+                <a:spcPts val="0"/>
+              </a:spcBef>
+              <a:spcAft>
+                <a:spcPts val="0"/>
+              </a:spcAft>
+              <a:buNone/>
+            </a:pPr>
+            <a:r>
+              <a:rPr lang="en-US"/>
+              <a:t>So — when does a search agent actually earn the word "agentic"? Our answer: when it can improve results on the fly, and fix the catalog itself. That happens through a loop, not a straight line: classify intent, retrieve, rerank, run a quality check, and — if that check fails — retry exactly once with adjusted parameters before moving on to answer and verify. That "retry once" is deliberate and bounded — this is not an open-ended agent loop that can spin forever; it gets one shot to do better, then it has to commit. Everything in the rest of this talk is really just zooming into different points on this loop.</a:t>
             </a:r>
             <a:endParaRPr/>
           </a:p>
@@ -2249,7 +2663,47 @@
               <a:buNone/>
             </a:pPr>
             <a:r>
+              <a:rPr lang="en-US"/>
+              <a:t>Structure</a:t>
+            </a:r>
+            <a:endParaRPr/>
+          </a:p>
+          <a:p>
+            <a:pPr indent="0" lvl="0" marL="0" rtl="0" algn="l">
+              <a:lnSpc>
+                <a:spcPct val="100000"/>
+              </a:lnSpc>
+              <a:spcBef>
+                <a:spcPts val="0"/>
+              </a:spcBef>
+              <a:spcAft>
+                <a:spcPts val="0"/>
+              </a:spcAft>
+              <a:buSzPts val="1100"/>
+              <a:buNone/>
+            </a:pPr>
+            <a:r>
               <a:t/>
+            </a:r>
+            <a:endParaRPr/>
+          </a:p>
+          <a:p>
+            <a:pPr indent="0" lvl="0" marL="0" rtl="0" algn="l">
+              <a:lnSpc>
+                <a:spcPct val="100000"/>
+              </a:lnSpc>
+              <a:spcBef>
+                <a:spcPts val="0"/>
+              </a:spcBef>
+              <a:spcAft>
+                <a:spcPts val="0"/>
+              </a:spcAft>
+              <a:buSzPts val="1100"/>
+              <a:buNone/>
+            </a:pPr>
+            <a:r>
+              <a:rPr lang="en-US"/>
+              <a:t>Three demos, one live application, no slide-to-slide fakery. Demo 1 is a single conversation where context carries forward turn to turn. Demo 2 takes one of those queries and scores it against real academic relevance judgments, not an internal metric we made up. Demo 3 is the centerpiece — a bad tag in the catalog, disputed by a user, fixed live, in front of you. The common thread: any query gets at most one retry and, when the catalog itself is wrong, one repair — this system enriches the catalog, not just the individual query.</a:t>
             </a:r>
             <a:endParaRPr/>
           </a:p>
@@ -2407,7 +2861,39 @@
               <a:buNone/>
             </a:pPr>
             <a:r>
+              <a:rPr lang="en-US"/>
+              <a:t>The Stack</a:t>
+            </a:r>
+            <a:endParaRPr/>
+          </a:p>
+          <a:p>
+            <a:pPr indent="0" lvl="0" marL="0" rtl="0" algn="l">
+              <a:spcBef>
+                <a:spcPts val="0"/>
+              </a:spcBef>
+              <a:spcAft>
+                <a:spcPts val="0"/>
+              </a:spcAft>
+              <a:buNone/>
+            </a:pPr>
+            <a:r>
               <a:t/>
+            </a:r>
+            <a:endParaRPr/>
+          </a:p>
+          <a:p>
+            <a:pPr indent="0" lvl="0" marL="0" rtl="0" algn="l">
+              <a:spcBef>
+                <a:spcPts val="0"/>
+              </a:spcBef>
+              <a:spcAft>
+                <a:spcPts val="0"/>
+              </a:spcAft>
+              <a:buNone/>
+            </a:pPr>
+            <a:r>
+              <a:rPr lang="en-US"/>
+              <a:t>End to end, this is one Docker Compose stack running entirely on my laptop — nothing here is calling out to a hosted backend except the model calls themselves. Lucille ingests and transforms documents; OpenSearch indexes them with both BM25 and HNSW vector search; a hybrid fusion layer retrieves and reranks with a local cross-encoder; LangGraph and LangChain orchestrate the reasoning, calling out to Gemini 2.5 Flash and Flash-Lite — that's the one piece that's cloud-hosted, on GCP, purely as a convenience; the same graph would run against a local model with no code changes. FastAPI and WebSocket serve it in real time with Postgres checkpointing state, and a React/Vite frontend gives us live visibility into what the agent is doing. All local, all live.</a:t>
             </a:r>
             <a:endParaRPr/>
           </a:p>
@@ -2479,7 +2965,47 @@
               <a:buNone/>
             </a:pPr>
             <a:r>
+              <a:rPr lang="en-US"/>
+              <a:t>Demo section divider</a:t>
+            </a:r>
+            <a:endParaRPr/>
+          </a:p>
+          <a:p>
+            <a:pPr indent="0" lvl="0" marL="0" rtl="0" algn="l">
+              <a:lnSpc>
+                <a:spcPct val="100000"/>
+              </a:lnSpc>
+              <a:spcBef>
+                <a:spcPts val="0"/>
+              </a:spcBef>
+              <a:spcAft>
+                <a:spcPts val="0"/>
+              </a:spcAft>
+              <a:buSzPts val="1100"/>
+              <a:buNone/>
+            </a:pPr>
+            <a:r>
               <a:t/>
+            </a:r>
+            <a:endParaRPr/>
+          </a:p>
+          <a:p>
+            <a:pPr indent="0" lvl="0" marL="0" rtl="0" algn="l">
+              <a:lnSpc>
+                <a:spcPct val="100000"/>
+              </a:lnSpc>
+              <a:spcBef>
+                <a:spcPts val="0"/>
+              </a:spcBef>
+              <a:spcAft>
+                <a:spcPts val="0"/>
+              </a:spcAft>
+              <a:buSzPts val="1100"/>
+              <a:buNone/>
+            </a:pPr>
+            <a:r>
+              <a:rPr lang="en-US"/>
+              <a:t>That's the architecture — now let's see it work. Three demos, starting with adaptive query enhancement.</a:t>
             </a:r>
             <a:endParaRPr/>
           </a:p>
@@ -2637,7 +3163,39 @@
               <a:buNone/>
             </a:pPr>
             <a:r>
+              <a:rPr lang="en-US"/>
+              <a:t>Demo 1 Recap</a:t>
+            </a:r>
+            <a:endParaRPr/>
+          </a:p>
+          <a:p>
+            <a:pPr indent="0" lvl="0" marL="0" rtl="0" algn="l">
+              <a:spcBef>
+                <a:spcPts val="0"/>
+              </a:spcBef>
+              <a:spcAft>
+                <a:spcPts val="0"/>
+              </a:spcAft>
+              <a:buNone/>
+            </a:pPr>
+            <a:r>
               <a:t/>
+            </a:r>
+            <a:endParaRPr/>
+          </a:p>
+          <a:p>
+            <a:pPr indent="0" lvl="0" marL="0" rtl="0" algn="l">
+              <a:spcBef>
+                <a:spcPts val="0"/>
+              </a:spcBef>
+              <a:spcAft>
+                <a:spcPts val="0"/>
+              </a:spcAft>
+              <a:buNone/>
+            </a:pPr>
+            <a:r>
+              <a:rPr lang="en-US"/>
+              <a:t>Three turns, one conversation, no re-typing filters. Turn one, "blue running shoes," comes back with alpha weighted toward lexical matching — 0.25 — because the query is literal, and both a color and a feature filter get applied automatically. Turn two, "only size 10," narrows the same ten results without re-searching at all — that's state, not a new query. Turn three, "what about trail running?" is where it gets interesting: alpha jumps to 0.70, semantic priority, because the question is no longer literal — and the rewrite carries both prior filters forward. Nobody set alpha per query; it climbed on its own as the questions got less literal. Under the hood, before hybrid search ever runs, the retriever node resolves that pronoun and comparative against conversation history — "what about trail running" plus the last two turns becomes "blue trail running shoes, size</a:t>
             </a:r>
             <a:endParaRPr/>
           </a:p>
@@ -27165,7 +27723,7 @@
                   <a:cs typeface="Calibri"/>
                   <a:sym typeface="Calibri"/>
                 </a:rPr>
-                <a:t>APPENDIX — FULL TOOLSET</a:t>
+                <a:t>FULL TOOLSET</a:t>
               </a:r>
               <a:endParaRPr b="1" i="0" sz="1350">
                 <a:solidFill>

</xml_diff>